<commit_message>
Ajout ressources sur git
</commit_message>
<xml_diff>
--- a/public/downloads/module-1/03-support-slides.pptx
+++ b/public/downloads/module-1/03-support-slides.pptx
@@ -4,6 +4,9 @@
   <p:sldMasterIdLst>
     <p:sldMasterId id="2147483648" r:id="rId1"/>
   </p:sldMasterIdLst>
+  <p:notesMasterIdLst>
+    <p:notesMasterId r:id="rId16"/>
+  </p:notesMasterIdLst>
   <p:sldIdLst>
     <p:sldId id="256" r:id="rId2"/>
     <p:sldId id="257" r:id="rId3"/>
@@ -20,9 +23,6 @@
     <p:sldId id="268" r:id="rId14"/>
     <p:sldId id="269" r:id="rId15"/>
   </p:sldIdLst>
-  <p:notesMasterIdLst>
-    <p:notesMasterId r:id="rId16"/>
-  </p:notesMasterIdLst>
   <p:sldSz cx="12192000" cy="6858000"/>
   <p:notesSz cx="6858000" cy="12192000"/>
   <p:defaultTextStyle>
@@ -117,6 +117,11 @@
       </a:defRPr>
     </a:lvl9pPr>
   </p:defaultTextStyle>
+  <p:extLst>
+    <p:ext uri="{EFAFB233-063F-42B5-8137-9DF3F51BA10A}">
+      <p15:sldGuideLst xmlns:p15="http://schemas.microsoft.com/office/powerpoint/2012/main"/>
+    </p:ext>
+  </p:extLst>
 </p:presentation>
 </file>
 
@@ -142,234 +147,10 @@
           <a:chExt cx="0" cy="0"/>
         </a:xfrm>
       </p:grpSpPr>
-      <p:sp>
-        <p:nvSpPr>
-          <p:cNvPr id="2" name="Header Placeholder 1"/>
-          <p:cNvSpPr>
-            <a:spLocks noGrp="1"/>
-          </p:cNvSpPr>
-          <p:nvPr>
-            <p:ph type="hdr" sz="quarter"/>
-          </p:nvPr>
-        </p:nvSpPr>
-        <p:spPr>
-          <a:xfrm>
-            <a:off x="0" y="0"/>
-            <a:ext cx="2971800" cy="458788"/>
-          </a:xfrm>
-          <a:prstGeom prst="rect">
-            <a:avLst/>
-          </a:prstGeom>
-        </p:spPr>
-        <p:txBody>
-          <a:bodyPr vert="horz" lIns="91440" tIns="45720" rIns="91440" bIns="45720" rtlCol="0"/>
-          <a:lstStyle>
-            <a:lvl1pPr algn="l">
-              <a:defRPr sz="1200"/>
-            </a:lvl1pPr>
-          </a:lstStyle>
-          <a:p>
-            <a:endParaRPr lang="en-US"/>
-          </a:p>
-        </p:txBody>
-      </p:sp>
-      <p:sp>
-        <p:nvSpPr>
-          <p:cNvPr id="3" name="Date Placeholder 2"/>
-          <p:cNvSpPr>
-            <a:spLocks noGrp="1"/>
-          </p:cNvSpPr>
-          <p:nvPr>
-            <p:ph type="dt" idx="1"/>
-          </p:nvPr>
-        </p:nvSpPr>
-        <p:spPr>
-          <a:xfrm>
-            <a:off x="3884613" y="0"/>
-            <a:ext cx="2971800" cy="458788"/>
-          </a:xfrm>
-          <a:prstGeom prst="rect">
-            <a:avLst/>
-          </a:prstGeom>
-        </p:spPr>
-        <p:txBody>
-          <a:bodyPr vert="horz" lIns="91440" tIns="45720" rIns="91440" bIns="45720" rtlCol="0"/>
-          <a:lstStyle>
-            <a:lvl1pPr algn="r">
-              <a:defRPr sz="1200"/>
-            </a:lvl1pPr>
-          </a:lstStyle>
-          <a:p>
-            <a:fld id="{5282F153-3F37-0F45-9E97-73ACFA13230C}" type="datetimeFigureOut">
-              <a:rPr lang="en-US"/>
-              <a:t>7/23/19</a:t>
-            </a:fld>
-            <a:endParaRPr lang="en-US"/>
-          </a:p>
-        </p:txBody>
-      </p:sp>
-      <p:sp>
-        <p:nvSpPr>
-          <p:cNvPr id="4" name="Slide Image Placeholder 3"/>
-          <p:cNvSpPr>
-            <a:spLocks noGrp="1" noRot="1" noChangeAspect="1"/>
-          </p:cNvSpPr>
-          <p:nvPr>
-            <p:ph type="sldImg" idx="2"/>
-          </p:nvPr>
-        </p:nvSpPr>
-        <p:spPr>
-          <a:xfrm>
-            <a:off x="685800" y="1143000"/>
-            <a:ext cx="5486400" cy="3086100"/>
-          </a:xfrm>
-          <a:prstGeom prst="rect">
-            <a:avLst/>
-          </a:prstGeom>
-          <a:noFill/>
-          <a:ln w="12700">
-            <a:solidFill>
-              <a:prstClr val="black"/>
-            </a:solidFill>
-          </a:ln>
-        </p:spPr>
-        <p:txBody>
-          <a:bodyPr vert="horz" lIns="91440" tIns="45720" rIns="91440" bIns="45720" rtlCol="0" anchor="ctr"/>
-          <a:lstStyle/>
-          <a:p>
-            <a:endParaRPr lang="en-US"/>
-          </a:p>
-        </p:txBody>
-      </p:sp>
-      <p:sp>
-        <p:nvSpPr>
-          <p:cNvPr id="5" name="Notes Placeholder 4"/>
-          <p:cNvSpPr>
-            <a:spLocks noGrp="1"/>
-          </p:cNvSpPr>
-          <p:nvPr>
-            <p:ph type="body" sz="quarter" idx="3"/>
-          </p:nvPr>
-        </p:nvSpPr>
-        <p:spPr>
-          <a:xfrm>
-            <a:off x="685800" y="4400550"/>
-            <a:ext cx="5486400" cy="3600450"/>
-          </a:xfrm>
-          <a:prstGeom prst="rect">
-            <a:avLst/>
-          </a:prstGeom>
-        </p:spPr>
-        <p:txBody>
-          <a:bodyPr vert="horz" lIns="91440" tIns="45720" rIns="91440" bIns="45720" rtlCol="0"/>
-          <a:lstStyle/>
-          <a:p>
-            <a:pPr lvl="0"/>
-            <a:r>
-              <a:rPr lang="en-US"/>
-              <a:t>Click to edit Master text styles</a:t>
-            </a:r>
-          </a:p>
-          <a:p>
-            <a:pPr lvl="1"/>
-            <a:r>
-              <a:rPr lang="en-US"/>
-              <a:t>Second level</a:t>
-            </a:r>
-          </a:p>
-          <a:p>
-            <a:pPr lvl="2"/>
-            <a:r>
-              <a:rPr lang="en-US"/>
-              <a:t>Third level</a:t>
-            </a:r>
-          </a:p>
-          <a:p>
-            <a:pPr lvl="3"/>
-            <a:r>
-              <a:rPr lang="en-US"/>
-              <a:t>Fourth level</a:t>
-            </a:r>
-          </a:p>
-          <a:p>
-            <a:pPr lvl="4"/>
-            <a:r>
-              <a:rPr lang="en-US"/>
-              <a:t>Fifth level</a:t>
-            </a:r>
-          </a:p>
-        </p:txBody>
-      </p:sp>
-      <p:sp>
-        <p:nvSpPr>
-          <p:cNvPr id="6" name="Footer Placeholder 5"/>
-          <p:cNvSpPr>
-            <a:spLocks noGrp="1"/>
-          </p:cNvSpPr>
-          <p:nvPr>
-            <p:ph type="ftr" sz="quarter" idx="4"/>
-          </p:nvPr>
-        </p:nvSpPr>
-        <p:spPr>
-          <a:xfrm>
-            <a:off x="0" y="8685213"/>
-            <a:ext cx="2971800" cy="458787"/>
-          </a:xfrm>
-          <a:prstGeom prst="rect">
-            <a:avLst/>
-          </a:prstGeom>
-        </p:spPr>
-        <p:txBody>
-          <a:bodyPr vert="horz" lIns="91440" tIns="45720" rIns="91440" bIns="45720" rtlCol="0" anchor="b"/>
-          <a:lstStyle>
-            <a:lvl1pPr algn="l">
-              <a:defRPr sz="1200"/>
-            </a:lvl1pPr>
-          </a:lstStyle>
-          <a:p>
-            <a:endParaRPr lang="en-US"/>
-          </a:p>
-        </p:txBody>
-      </p:sp>
-      <p:sp>
-        <p:nvSpPr>
-          <p:cNvPr id="7" name="Slide Number Placeholder 6"/>
-          <p:cNvSpPr>
-            <a:spLocks noGrp="1"/>
-          </p:cNvSpPr>
-          <p:nvPr>
-            <p:ph type="sldNum" sz="quarter" idx="5"/>
-          </p:nvPr>
-        </p:nvSpPr>
-        <p:spPr>
-          <a:xfrm>
-            <a:off x="3884613" y="8685213"/>
-            <a:ext cx="2971800" cy="458787"/>
-          </a:xfrm>
-          <a:prstGeom prst="rect">
-            <a:avLst/>
-          </a:prstGeom>
-        </p:spPr>
-        <p:txBody>
-          <a:bodyPr vert="horz" lIns="91440" tIns="45720" rIns="91440" bIns="45720" rtlCol="0" anchor="b"/>
-          <a:lstStyle>
-            <a:lvl1pPr algn="r">
-              <a:defRPr sz="1200"/>
-            </a:lvl1pPr>
-          </a:lstStyle>
-          <a:p>
-            <a:fld id="{CE5E9CC1-C706-0F49-92D6-E571CC5EEA8F}" type="slidenum">
-              <a:rPr lang="en-US"/>
-              <a:t>‹#›</a:t>
-            </a:fld>
-            <a:endParaRPr lang="en-US"/>
-          </a:p>
-        </p:txBody>
-      </p:sp>
     </p:spTree>
     <p:extLst>
       <p:ext uri="{BB962C8B-B14F-4D97-AF65-F5344CB8AC3E}">
-        <p14:creationId xmlns:p14="http://schemas.microsoft.com/office/powerpoint/2010/main" val="1024086991"/>
+        <p14:creationId xmlns:p14="http://schemas.microsoft.com/office/powerpoint/2010/main" val="3557625579"/>
       </p:ext>
     </p:extLst>
   </p:cSld>
@@ -513,10 +294,6 @@
           <a:bodyPr/>
           <a:lstStyle/>
           <a:p>
-            <a:r>
-              <a:rPr lang="en-US" dirty="0"/>
-              <a:t/>
-            </a:r>
             <a:endParaRPr lang="en-US" dirty="0"/>
           </a:p>
         </p:txBody>
@@ -601,10 +378,6 @@
           <a:bodyPr/>
           <a:lstStyle/>
           <a:p>
-            <a:r>
-              <a:rPr lang="en-US" dirty="0"/>
-              <a:t/>
-            </a:r>
             <a:endParaRPr lang="en-US" dirty="0"/>
           </a:p>
         </p:txBody>
@@ -689,10 +462,6 @@
           <a:bodyPr/>
           <a:lstStyle/>
           <a:p>
-            <a:r>
-              <a:rPr lang="en-US" dirty="0"/>
-              <a:t/>
-            </a:r>
             <a:endParaRPr lang="en-US" dirty="0"/>
           </a:p>
         </p:txBody>
@@ -777,10 +546,6 @@
           <a:bodyPr/>
           <a:lstStyle/>
           <a:p>
-            <a:r>
-              <a:rPr lang="en-US" dirty="0"/>
-              <a:t/>
-            </a:r>
             <a:endParaRPr lang="en-US" dirty="0"/>
           </a:p>
         </p:txBody>
@@ -865,10 +630,6 @@
           <a:bodyPr/>
           <a:lstStyle/>
           <a:p>
-            <a:r>
-              <a:rPr lang="en-US" dirty="0"/>
-              <a:t/>
-            </a:r>
             <a:endParaRPr lang="en-US" dirty="0"/>
           </a:p>
         </p:txBody>
@@ -953,10 +714,6 @@
           <a:bodyPr/>
           <a:lstStyle/>
           <a:p>
-            <a:r>
-              <a:rPr lang="en-US" dirty="0"/>
-              <a:t/>
-            </a:r>
             <a:endParaRPr lang="en-US" dirty="0"/>
           </a:p>
         </p:txBody>
@@ -1041,10 +798,6 @@
           <a:bodyPr/>
           <a:lstStyle/>
           <a:p>
-            <a:r>
-              <a:rPr lang="en-US" dirty="0"/>
-              <a:t/>
-            </a:r>
             <a:endParaRPr lang="en-US" dirty="0"/>
           </a:p>
         </p:txBody>
@@ -1129,10 +882,6 @@
           <a:bodyPr/>
           <a:lstStyle/>
           <a:p>
-            <a:r>
-              <a:rPr lang="en-US" dirty="0"/>
-              <a:t/>
-            </a:r>
             <a:endParaRPr lang="en-US" dirty="0"/>
           </a:p>
         </p:txBody>
@@ -1217,10 +966,6 @@
           <a:bodyPr/>
           <a:lstStyle/>
           <a:p>
-            <a:r>
-              <a:rPr lang="en-US" dirty="0"/>
-              <a:t/>
-            </a:r>
             <a:endParaRPr lang="en-US" dirty="0"/>
           </a:p>
         </p:txBody>
@@ -1305,10 +1050,6 @@
           <a:bodyPr/>
           <a:lstStyle/>
           <a:p>
-            <a:r>
-              <a:rPr lang="en-US" dirty="0"/>
-              <a:t/>
-            </a:r>
             <a:endParaRPr lang="en-US" dirty="0"/>
           </a:p>
         </p:txBody>
@@ -1393,10 +1134,6 @@
           <a:bodyPr/>
           <a:lstStyle/>
           <a:p>
-            <a:r>
-              <a:rPr lang="en-US" dirty="0"/>
-              <a:t/>
-            </a:r>
             <a:endParaRPr lang="en-US" dirty="0"/>
           </a:p>
         </p:txBody>
@@ -1481,10 +1218,6 @@
           <a:bodyPr/>
           <a:lstStyle/>
           <a:p>
-            <a:r>
-              <a:rPr lang="en-US" dirty="0"/>
-              <a:t/>
-            </a:r>
             <a:endParaRPr lang="en-US" dirty="0"/>
           </a:p>
         </p:txBody>
@@ -1569,10 +1302,6 @@
           <a:bodyPr/>
           <a:lstStyle/>
           <a:p>
-            <a:r>
-              <a:rPr lang="en-US" dirty="0"/>
-              <a:t/>
-            </a:r>
             <a:endParaRPr lang="en-US" dirty="0"/>
           </a:p>
         </p:txBody>
@@ -1657,10 +1386,6 @@
           <a:bodyPr/>
           <a:lstStyle/>
           <a:p>
-            <a:r>
-              <a:rPr lang="en-US" dirty="0"/>
-              <a:t/>
-            </a:r>
             <a:endParaRPr lang="en-US" dirty="0"/>
           </a:p>
         </p:txBody>
@@ -1734,6 +1459,11 @@
 <file path=ppt/slideMasters/slideMaster1.xml><?xml version="1.0" encoding="utf-8"?>
 <p:sldMaster xmlns:a="http://schemas.openxmlformats.org/drawingml/2006/main" xmlns:r="http://schemas.openxmlformats.org/officeDocument/2006/relationships" xmlns:p="http://schemas.openxmlformats.org/presentationml/2006/main">
   <p:cSld>
+    <p:bg>
+      <p:bgRef idx="1001">
+        <a:schemeClr val="bg1"/>
+      </p:bgRef>
+    </p:bg>
     <p:spTree>
       <p:nvGrpSpPr>
         <p:cNvPr id="1" name=""/>
@@ -2016,6 +1746,7 @@
         <a:solidFill>
           <a:srgbClr val="FDF3F0"/>
         </a:solidFill>
+        <a:effectLst/>
       </p:bgPr>
     </p:bg>
     <p:spTree>
@@ -2053,7 +1784,7 @@
           <a:bodyPr wrap="square" lIns="0" tIns="0" rIns="0" bIns="0" rtlCol="0" anchor="ctr"/>
           <a:lstStyle/>
           <a:p>
-            <a:pPr algn="ctr" indent="0" marL="0">
+            <a:pPr marL="0" indent="0" algn="ctr">
               <a:buNone/>
             </a:pPr>
             <a:r>
@@ -2092,7 +1823,7 @@
           <a:bodyPr wrap="square" lIns="0" tIns="0" rIns="0" bIns="0" rtlCol="0" anchor="ctr"/>
           <a:lstStyle/>
           <a:p>
-            <a:pPr algn="ctr" indent="0" marL="0">
+            <a:pPr marL="0" indent="0" algn="ctr">
               <a:buNone/>
             </a:pPr>
             <a:r>
@@ -2131,7 +1862,7 @@
           <a:bodyPr wrap="square" lIns="0" tIns="0" rIns="0" bIns="0" rtlCol="0" anchor="ctr"/>
           <a:lstStyle/>
           <a:p>
-            <a:pPr algn="ctr" indent="0" marL="0">
+            <a:pPr marL="0" indent="0" algn="ctr">
               <a:buNone/>
             </a:pPr>
             <a:r>
@@ -2170,7 +1901,7 @@
           <a:bodyPr wrap="square" lIns="0" tIns="0" rIns="0" bIns="0" rtlCol="0" anchor="ctr"/>
           <a:lstStyle/>
           <a:p>
-            <a:pPr algn="ctr" indent="0" marL="0">
+            <a:pPr marL="0" indent="0" algn="ctr">
               <a:buNone/>
             </a:pPr>
             <a:r>
@@ -2209,6 +1940,13 @@
           </a:solidFill>
           <a:ln/>
         </p:spPr>
+        <p:txBody>
+          <a:bodyPr/>
+          <a:lstStyle/>
+          <a:p>
+            <a:endParaRPr lang="fr-FR"/>
+          </a:p>
+        </p:txBody>
       </p:sp>
       <p:sp>
         <p:nvSpPr>
@@ -2231,7 +1969,7 @@
           <a:bodyPr wrap="square" lIns="0" tIns="0" rIns="0" bIns="0" rtlCol="0" anchor="ctr"/>
           <a:lstStyle/>
           <a:p>
-            <a:pPr algn="ctr" indent="0" marL="0">
+            <a:pPr marL="0" indent="0" algn="ctr">
               <a:buNone/>
             </a:pPr>
             <a:r>
@@ -2270,7 +2008,7 @@
           <a:bodyPr wrap="square" lIns="0" tIns="0" rIns="0" bIns="0" rtlCol="0" anchor="t"/>
           <a:lstStyle/>
           <a:p>
-            <a:pPr algn="l" indent="0" marL="0">
+            <a:pPr marL="0" indent="0" algn="l">
               <a:buNone/>
             </a:pPr>
             <a:r>
@@ -2309,7 +2047,7 @@
           <a:bodyPr wrap="square" lIns="0" tIns="0" rIns="0" bIns="0" rtlCol="0" anchor="ctr"/>
           <a:lstStyle/>
           <a:p>
-            <a:pPr algn="l" indent="0" marL="0">
+            <a:pPr marL="0" indent="0" algn="l">
               <a:buNone/>
             </a:pPr>
             <a:r>
@@ -2348,6 +2086,13 @@
           </a:solidFill>
           <a:ln/>
         </p:spPr>
+        <p:txBody>
+          <a:bodyPr/>
+          <a:lstStyle/>
+          <a:p>
+            <a:endParaRPr lang="fr-FR"/>
+          </a:p>
+        </p:txBody>
       </p:sp>
       <p:sp>
         <p:nvSpPr>
@@ -2370,7 +2115,7 @@
           <a:bodyPr wrap="square" lIns="0" tIns="0" rIns="0" bIns="0" rtlCol="0" anchor="ctr"/>
           <a:lstStyle/>
           <a:p>
-            <a:pPr algn="ctr" indent="0" marL="0">
+            <a:pPr marL="0" indent="0" algn="ctr">
               <a:buNone/>
             </a:pPr>
             <a:r>
@@ -2404,6 +2149,7 @@
         <a:solidFill>
           <a:srgbClr val="FDF3F0"/>
         </a:solidFill>
+        <a:effectLst/>
       </p:bgPr>
     </p:bg>
     <p:spTree>
@@ -2441,7 +2187,7 @@
           <a:bodyPr wrap="square" lIns="0" tIns="0" rIns="0" bIns="0" rtlCol="0" anchor="ctr"/>
           <a:lstStyle/>
           <a:p>
-            <a:pPr algn="ctr" indent="0" marL="0">
+            <a:pPr marL="0" indent="0" algn="ctr">
               <a:buNone/>
             </a:pPr>
             <a:r>
@@ -2480,7 +2226,7 @@
           <a:bodyPr wrap="square" lIns="0" tIns="0" rIns="0" bIns="0" rtlCol="0" anchor="ctr"/>
           <a:lstStyle/>
           <a:p>
-            <a:pPr algn="ctr" indent="0" marL="0">
+            <a:pPr marL="0" indent="0" algn="ctr">
               <a:buNone/>
             </a:pPr>
             <a:r>
@@ -2519,7 +2265,7 @@
           <a:bodyPr wrap="square" lIns="0" tIns="0" rIns="0" bIns="0" rtlCol="0" anchor="ctr"/>
           <a:lstStyle/>
           <a:p>
-            <a:pPr algn="ctr" indent="0" marL="0">
+            <a:pPr marL="0" indent="0" algn="ctr">
               <a:buNone/>
             </a:pPr>
             <a:r>
@@ -2558,7 +2304,7 @@
           <a:bodyPr wrap="square" lIns="0" tIns="0" rIns="0" bIns="0" rtlCol="0" anchor="ctr"/>
           <a:lstStyle/>
           <a:p>
-            <a:pPr algn="ctr" indent="0" marL="0">
+            <a:pPr marL="0" indent="0" algn="ctr">
               <a:buNone/>
             </a:pPr>
             <a:r>
@@ -2595,6 +2341,13 @@
           </a:solidFill>
           <a:ln/>
         </p:spPr>
+        <p:txBody>
+          <a:bodyPr/>
+          <a:lstStyle/>
+          <a:p>
+            <a:endParaRPr lang="fr-FR"/>
+          </a:p>
+        </p:txBody>
       </p:sp>
       <p:sp>
         <p:nvSpPr>
@@ -2617,7 +2370,7 @@
           <a:bodyPr wrap="square" lIns="0" tIns="0" rIns="0" bIns="0" rtlCol="0" anchor="ctr"/>
           <a:lstStyle/>
           <a:p>
-            <a:pPr algn="ctr" indent="0" marL="0">
+            <a:pPr marL="0" indent="0" algn="ctr">
               <a:buNone/>
             </a:pPr>
             <a:r>
@@ -2656,7 +2409,7 @@
           <a:bodyPr wrap="square" lIns="0" tIns="0" rIns="0" bIns="0" rtlCol="0" anchor="ctr"/>
           <a:lstStyle/>
           <a:p>
-            <a:pPr algn="l" indent="0" marL="0">
+            <a:pPr marL="0" indent="0" algn="l">
               <a:buNone/>
             </a:pPr>
             <a:r>
@@ -2695,7 +2448,7 @@
           <a:bodyPr wrap="square" lIns="0" tIns="0" rIns="0" bIns="0" rtlCol="0" anchor="t"/>
           <a:lstStyle/>
           <a:p>
-            <a:pPr algn="l" indent="0" marL="0">
+            <a:pPr marL="0" indent="0" algn="l">
               <a:buNone/>
             </a:pPr>
             <a:r>
@@ -2709,12 +2462,6 @@
               </a:rPr>
               <a:t>●  </a:t>
             </a:r>
-            <a:pPr algn="l" indent="0" marL="0">
-              <a:spcAft>
-                <a:spcPts val="1400"/>
-              </a:spcAft>
-              <a:buNone/>
-            </a:pPr>
             <a:r>
               <a:rPr lang="en-US" sz="1600" dirty="0">
                 <a:solidFill>
@@ -2729,7 +2476,7 @@
             <a:endParaRPr lang="en-US" sz="1600" dirty="0"/>
           </a:p>
           <a:p>
-            <a:pPr algn="l" indent="0" marL="0">
+            <a:pPr marL="0" indent="0" algn="l">
               <a:buNone/>
             </a:pPr>
             <a:r>
@@ -2743,9 +2490,6 @@
               </a:rPr>
               <a:t>●  </a:t>
             </a:r>
-            <a:pPr algn="l" indent="0" marL="0">
-              <a:buNone/>
-            </a:pPr>
             <a:r>
               <a:rPr lang="en-US" sz="1600" dirty="0">
                 <a:solidFill>
@@ -2782,6 +2526,13 @@
           </a:solidFill>
           <a:ln/>
         </p:spPr>
+        <p:txBody>
+          <a:bodyPr/>
+          <a:lstStyle/>
+          <a:p>
+            <a:endParaRPr lang="fr-FR"/>
+          </a:p>
+        </p:txBody>
       </p:sp>
       <p:sp>
         <p:nvSpPr>
@@ -2804,7 +2555,7 @@
           <a:bodyPr wrap="square" lIns="0" tIns="0" rIns="0" bIns="0" rtlCol="0" anchor="ctr"/>
           <a:lstStyle/>
           <a:p>
-            <a:pPr algn="l" indent="0" marL="0">
+            <a:pPr marL="0" indent="0" algn="l">
               <a:buNone/>
             </a:pPr>
             <a:r>
@@ -2843,7 +2594,7 @@
           <a:bodyPr wrap="square" lIns="0" tIns="0" rIns="0" bIns="0" rtlCol="0" anchor="t"/>
           <a:lstStyle/>
           <a:p>
-            <a:pPr algn="l" indent="0" marL="0">
+            <a:pPr marL="0" indent="0" algn="l">
               <a:buNone/>
             </a:pPr>
             <a:r>
@@ -2857,9 +2608,6 @@
               </a:rPr>
               <a:t>●  </a:t>
             </a:r>
-            <a:pPr algn="l" indent="0" marL="0">
-              <a:buNone/>
-            </a:pPr>
             <a:r>
               <a:rPr lang="en-US" sz="1500" dirty="0">
                 <a:solidFill>
@@ -2891,6 +2639,7 @@
         <a:solidFill>
           <a:srgbClr val="1A1323"/>
         </a:solidFill>
+        <a:effectLst/>
       </p:bgPr>
     </p:bg>
     <p:spTree>
@@ -2926,6 +2675,13 @@
           </a:solidFill>
           <a:ln/>
         </p:spPr>
+        <p:txBody>
+          <a:bodyPr/>
+          <a:lstStyle/>
+          <a:p>
+            <a:endParaRPr lang="fr-FR"/>
+          </a:p>
+        </p:txBody>
       </p:sp>
       <p:sp>
         <p:nvSpPr>
@@ -2948,7 +2704,7 @@
           <a:bodyPr wrap="square" lIns="0" tIns="0" rIns="0" bIns="0" rtlCol="0" anchor="ctr"/>
           <a:lstStyle/>
           <a:p>
-            <a:pPr algn="ctr" indent="0" marL="0">
+            <a:pPr marL="0" indent="0" algn="ctr">
               <a:buNone/>
             </a:pPr>
             <a:r>
@@ -2987,7 +2743,7 @@
           <a:bodyPr wrap="square" lIns="0" tIns="0" rIns="0" bIns="0" rtlCol="0" anchor="ctr"/>
           <a:lstStyle/>
           <a:p>
-            <a:pPr algn="l" indent="0" marL="0">
+            <a:pPr marL="0" indent="0" algn="l">
               <a:buNone/>
             </a:pPr>
             <a:r>
@@ -3026,7 +2782,7 @@
           <a:bodyPr wrap="square" lIns="0" tIns="0" rIns="0" bIns="0" rtlCol="0" anchor="t"/>
           <a:lstStyle/>
           <a:p>
-            <a:pPr algn="l" indent="0" marL="0">
+            <a:pPr marL="0" indent="0" algn="l">
               <a:buNone/>
             </a:pPr>
             <a:r>
@@ -3065,7 +2821,7 @@
           <a:bodyPr wrap="square" lIns="0" tIns="0" rIns="0" bIns="0" rtlCol="0" anchor="t"/>
           <a:lstStyle/>
           <a:p>
-            <a:pPr algn="l" indent="0" marL="0">
+            <a:pPr marL="0" indent="0" algn="l">
               <a:buNone/>
             </a:pPr>
             <a:r>
@@ -3099,6 +2855,7 @@
         <a:solidFill>
           <a:srgbClr val="FDF3F0"/>
         </a:solidFill>
+        <a:effectLst/>
       </p:bgPr>
     </p:bg>
     <p:spTree>
@@ -3136,7 +2893,7 @@
           <a:bodyPr wrap="square" lIns="0" tIns="0" rIns="0" bIns="0" rtlCol="0" anchor="ctr"/>
           <a:lstStyle/>
           <a:p>
-            <a:pPr algn="ctr" indent="0" marL="0">
+            <a:pPr marL="0" indent="0" algn="ctr">
               <a:buNone/>
             </a:pPr>
             <a:r>
@@ -3175,7 +2932,7 @@
           <a:bodyPr wrap="square" lIns="0" tIns="0" rIns="0" bIns="0" rtlCol="0" anchor="ctr"/>
           <a:lstStyle/>
           <a:p>
-            <a:pPr algn="ctr" indent="0" marL="0">
+            <a:pPr marL="0" indent="0" algn="ctr">
               <a:buNone/>
             </a:pPr>
             <a:r>
@@ -3214,7 +2971,7 @@
           <a:bodyPr wrap="square" lIns="0" tIns="0" rIns="0" bIns="0" rtlCol="0" anchor="ctr"/>
           <a:lstStyle/>
           <a:p>
-            <a:pPr algn="ctr" indent="0" marL="0">
+            <a:pPr marL="0" indent="0" algn="ctr">
               <a:buNone/>
             </a:pPr>
             <a:r>
@@ -3253,7 +3010,7 @@
           <a:bodyPr wrap="square" lIns="0" tIns="0" rIns="0" bIns="0" rtlCol="0" anchor="ctr"/>
           <a:lstStyle/>
           <a:p>
-            <a:pPr algn="ctr" indent="0" marL="0">
+            <a:pPr marL="0" indent="0" algn="ctr">
               <a:buNone/>
             </a:pPr>
             <a:r>
@@ -3290,6 +3047,13 @@
           </a:solidFill>
           <a:ln/>
         </p:spPr>
+        <p:txBody>
+          <a:bodyPr/>
+          <a:lstStyle/>
+          <a:p>
+            <a:endParaRPr lang="fr-FR"/>
+          </a:p>
+        </p:txBody>
       </p:sp>
       <p:sp>
         <p:nvSpPr>
@@ -3312,7 +3076,7 @@
           <a:bodyPr wrap="square" lIns="0" tIns="0" rIns="0" bIns="0" rtlCol="0" anchor="ctr"/>
           <a:lstStyle/>
           <a:p>
-            <a:pPr algn="ctr" indent="0" marL="0">
+            <a:pPr marL="0" indent="0" algn="ctr">
               <a:buNone/>
             </a:pPr>
             <a:r>
@@ -3351,7 +3115,7 @@
           <a:bodyPr wrap="square" lIns="0" tIns="0" rIns="0" bIns="0" rtlCol="0" anchor="ctr"/>
           <a:lstStyle/>
           <a:p>
-            <a:pPr algn="l" indent="0" marL="0">
+            <a:pPr marL="0" indent="0" algn="l">
               <a:buNone/>
             </a:pPr>
             <a:r>
@@ -3390,7 +3154,7 @@
           <a:bodyPr wrap="square" lIns="0" tIns="0" rIns="0" bIns="0" rtlCol="0" anchor="t"/>
           <a:lstStyle/>
           <a:p>
-            <a:pPr algn="l" indent="0" marL="0">
+            <a:pPr marL="0" indent="0" algn="l">
               <a:buNone/>
             </a:pPr>
             <a:r>
@@ -3404,12 +3168,6 @@
               </a:rPr>
               <a:t>●  </a:t>
             </a:r>
-            <a:pPr algn="l" indent="0" marL="0">
-              <a:spcAft>
-                <a:spcPts val="1400"/>
-              </a:spcAft>
-              <a:buNone/>
-            </a:pPr>
             <a:r>
               <a:rPr lang="en-US" sz="1500" dirty="0">
                 <a:solidFill>
@@ -3424,7 +3182,7 @@
             <a:endParaRPr lang="en-US" sz="1500" dirty="0"/>
           </a:p>
           <a:p>
-            <a:pPr algn="l" indent="0" marL="0">
+            <a:pPr marL="0" indent="0" algn="l">
               <a:buNone/>
             </a:pPr>
             <a:r>
@@ -3438,12 +3196,6 @@
               </a:rPr>
               <a:t>●  </a:t>
             </a:r>
-            <a:pPr algn="l" indent="0" marL="0">
-              <a:spcAft>
-                <a:spcPts val="1400"/>
-              </a:spcAft>
-              <a:buNone/>
-            </a:pPr>
             <a:r>
               <a:rPr lang="en-US" sz="1500" dirty="0">
                 <a:solidFill>
@@ -3458,7 +3210,7 @@
             <a:endParaRPr lang="en-US" sz="1500" dirty="0"/>
           </a:p>
           <a:p>
-            <a:pPr algn="l" indent="0" marL="0">
+            <a:pPr marL="0" indent="0" algn="l">
               <a:buNone/>
             </a:pPr>
             <a:r>
@@ -3472,9 +3224,6 @@
               </a:rPr>
               <a:t>●  </a:t>
             </a:r>
-            <a:pPr algn="l" indent="0" marL="0">
-              <a:buNone/>
-            </a:pPr>
             <a:r>
               <a:rPr lang="en-US" sz="1500" dirty="0">
                 <a:solidFill>
@@ -3511,6 +3260,13 @@
           </a:solidFill>
           <a:ln/>
         </p:spPr>
+        <p:txBody>
+          <a:bodyPr/>
+          <a:lstStyle/>
+          <a:p>
+            <a:endParaRPr lang="fr-FR"/>
+          </a:p>
+        </p:txBody>
       </p:sp>
       <p:sp>
         <p:nvSpPr>
@@ -3533,7 +3289,7 @@
           <a:bodyPr wrap="square" lIns="0" tIns="0" rIns="0" bIns="0" rtlCol="0" anchor="ctr"/>
           <a:lstStyle/>
           <a:p>
-            <a:pPr algn="l" indent="0" marL="0">
+            <a:pPr marL="0" indent="0" algn="l">
               <a:buNone/>
             </a:pPr>
             <a:r>
@@ -3572,7 +3328,7 @@
           <a:bodyPr wrap="square" lIns="0" tIns="0" rIns="0" bIns="0" rtlCol="0" anchor="t"/>
           <a:lstStyle/>
           <a:p>
-            <a:pPr algn="l" indent="0" marL="0">
+            <a:pPr marL="0" indent="0" algn="l">
               <a:buNone/>
             </a:pPr>
             <a:r>
@@ -3586,9 +3342,6 @@
               </a:rPr>
               <a:t>●  </a:t>
             </a:r>
-            <a:pPr algn="l" indent="0" marL="0">
-              <a:buNone/>
-            </a:pPr>
             <a:r>
               <a:rPr lang="en-US" sz="1500" dirty="0">
                 <a:solidFill>
@@ -3620,6 +3373,7 @@
         <a:solidFill>
           <a:srgbClr val="FDF3F0"/>
         </a:solidFill>
+        <a:effectLst/>
       </p:bgPr>
     </p:bg>
     <p:spTree>
@@ -3657,7 +3411,7 @@
           <a:bodyPr wrap="square" lIns="0" tIns="0" rIns="0" bIns="0" rtlCol="0" anchor="ctr"/>
           <a:lstStyle/>
           <a:p>
-            <a:pPr algn="ctr" indent="0" marL="0">
+            <a:pPr marL="0" indent="0" algn="ctr">
               <a:buNone/>
             </a:pPr>
             <a:r>
@@ -3696,7 +3450,7 @@
           <a:bodyPr wrap="square" lIns="0" tIns="0" rIns="0" bIns="0" rtlCol="0" anchor="ctr"/>
           <a:lstStyle/>
           <a:p>
-            <a:pPr algn="ctr" indent="0" marL="0">
+            <a:pPr marL="0" indent="0" algn="ctr">
               <a:buNone/>
             </a:pPr>
             <a:r>
@@ -3735,7 +3489,7 @@
           <a:bodyPr wrap="square" lIns="0" tIns="0" rIns="0" bIns="0" rtlCol="0" anchor="ctr"/>
           <a:lstStyle/>
           <a:p>
-            <a:pPr algn="ctr" indent="0" marL="0">
+            <a:pPr marL="0" indent="0" algn="ctr">
               <a:buNone/>
             </a:pPr>
             <a:r>
@@ -3774,7 +3528,7 @@
           <a:bodyPr wrap="square" lIns="0" tIns="0" rIns="0" bIns="0" rtlCol="0" anchor="ctr"/>
           <a:lstStyle/>
           <a:p>
-            <a:pPr algn="ctr" indent="0" marL="0">
+            <a:pPr marL="0" indent="0" algn="ctr">
               <a:buNone/>
             </a:pPr>
             <a:r>
@@ -3813,7 +3567,7 @@
           <a:bodyPr wrap="square" lIns="0" tIns="0" rIns="0" bIns="0" rtlCol="0" anchor="t"/>
           <a:lstStyle/>
           <a:p>
-            <a:pPr algn="l" indent="0" marL="0">
+            <a:pPr marL="0" indent="0" algn="l">
               <a:buNone/>
             </a:pPr>
             <a:r>
@@ -3852,7 +3606,7 @@
           <a:bodyPr wrap="square" lIns="0" tIns="0" rIns="0" bIns="0" rtlCol="0" anchor="t"/>
           <a:lstStyle/>
           <a:p>
-            <a:pPr algn="l" indent="0" marL="0">
+            <a:pPr marL="0" indent="0" algn="l">
               <a:buNone/>
             </a:pPr>
             <a:r>
@@ -3891,6 +3645,13 @@
           </a:solidFill>
           <a:ln/>
         </p:spPr>
+        <p:txBody>
+          <a:bodyPr/>
+          <a:lstStyle/>
+          <a:p>
+            <a:endParaRPr lang="fr-FR"/>
+          </a:p>
+        </p:txBody>
       </p:sp>
       <p:sp>
         <p:nvSpPr>
@@ -3913,7 +3674,7 @@
           <a:bodyPr wrap="square" lIns="0" tIns="0" rIns="0" bIns="0" rtlCol="0" anchor="ctr"/>
           <a:lstStyle/>
           <a:p>
-            <a:pPr algn="ctr" indent="0" marL="0">
+            <a:pPr marL="0" indent="0" algn="ctr">
               <a:buNone/>
             </a:pPr>
             <a:r>
@@ -3930,7 +3691,7 @@
             <a:endParaRPr lang="en-US" sz="1100" dirty="0"/>
           </a:p>
           <a:p>
-            <a:pPr algn="ctr" indent="0" marL="0">
+            <a:pPr marL="0" indent="0" algn="ctr">
               <a:buNone/>
             </a:pPr>
             <a:r>
@@ -3969,7 +3730,7 @@
           <a:bodyPr wrap="square" lIns="0" tIns="0" rIns="0" bIns="0" rtlCol="0" anchor="ctr"/>
           <a:lstStyle/>
           <a:p>
-            <a:pPr algn="ctr" indent="0" marL="0">
+            <a:pPr marL="0" indent="0" algn="ctr">
               <a:buNone/>
             </a:pPr>
             <a:r>
@@ -3986,7 +3747,7 @@
             <a:endParaRPr lang="en-US" sz="4000" dirty="0"/>
           </a:p>
           <a:p>
-            <a:pPr algn="ctr" indent="0" marL="0">
+            <a:pPr marL="0" indent="0" algn="ctr">
               <a:buNone/>
             </a:pPr>
             <a:r>
@@ -4020,6 +3781,7 @@
         <a:solidFill>
           <a:srgbClr val="FDF3F0"/>
         </a:solidFill>
+        <a:effectLst/>
       </p:bgPr>
     </p:bg>
     <p:spTree>
@@ -4057,7 +3819,7 @@
           <a:bodyPr wrap="square" lIns="0" tIns="0" rIns="0" bIns="0" rtlCol="0" anchor="ctr"/>
           <a:lstStyle/>
           <a:p>
-            <a:pPr algn="ctr" indent="0" marL="0">
+            <a:pPr marL="0" indent="0" algn="ctr">
               <a:buNone/>
             </a:pPr>
             <a:r>
@@ -4096,7 +3858,7 @@
           <a:bodyPr wrap="square" lIns="0" tIns="0" rIns="0" bIns="0" rtlCol="0" anchor="ctr"/>
           <a:lstStyle/>
           <a:p>
-            <a:pPr algn="ctr" indent="0" marL="0">
+            <a:pPr marL="0" indent="0" algn="ctr">
               <a:buNone/>
             </a:pPr>
             <a:r>
@@ -4135,7 +3897,7 @@
           <a:bodyPr wrap="square" lIns="0" tIns="0" rIns="0" bIns="0" rtlCol="0" anchor="ctr"/>
           <a:lstStyle/>
           <a:p>
-            <a:pPr algn="ctr" indent="0" marL="0">
+            <a:pPr marL="0" indent="0" algn="ctr">
               <a:buNone/>
             </a:pPr>
             <a:r>
@@ -4174,7 +3936,7 @@
           <a:bodyPr wrap="square" lIns="0" tIns="0" rIns="0" bIns="0" rtlCol="0" anchor="ctr"/>
           <a:lstStyle/>
           <a:p>
-            <a:pPr algn="ctr" indent="0" marL="0">
+            <a:pPr marL="0" indent="0" algn="ctr">
               <a:buNone/>
             </a:pPr>
             <a:r>
@@ -4213,7 +3975,7 @@
           <a:bodyPr wrap="square" lIns="0" tIns="0" rIns="0" bIns="0" rtlCol="0" anchor="ctr"/>
           <a:lstStyle/>
           <a:p>
-            <a:pPr algn="l" indent="0" marL="0">
+            <a:pPr marL="0" indent="0" algn="l">
               <a:buNone/>
             </a:pPr>
             <a:r>
@@ -4252,7 +4014,7 @@
           <a:bodyPr wrap="square" lIns="0" tIns="0" rIns="0" bIns="0" rtlCol="0" anchor="ctr"/>
           <a:lstStyle/>
           <a:p>
-            <a:pPr algn="l" indent="0" marL="0">
+            <a:pPr marL="0" indent="0" algn="l">
               <a:buNone/>
             </a:pPr>
             <a:r>
@@ -4291,6 +4053,13 @@
           </a:solidFill>
           <a:ln/>
         </p:spPr>
+        <p:txBody>
+          <a:bodyPr/>
+          <a:lstStyle/>
+          <a:p>
+            <a:endParaRPr lang="fr-FR"/>
+          </a:p>
+        </p:txBody>
       </p:sp>
       <p:sp>
         <p:nvSpPr>
@@ -4311,6 +4080,13 @@
           </a:solidFill>
           <a:ln/>
         </p:spPr>
+        <p:txBody>
+          <a:bodyPr/>
+          <a:lstStyle/>
+          <a:p>
+            <a:endParaRPr lang="fr-FR"/>
+          </a:p>
+        </p:txBody>
       </p:sp>
       <p:sp>
         <p:nvSpPr>
@@ -4333,7 +4109,7 @@
           <a:bodyPr wrap="square" lIns="0" tIns="0" rIns="0" bIns="0" rtlCol="0" anchor="ctr"/>
           <a:lstStyle/>
           <a:p>
-            <a:pPr algn="ctr" indent="0" marL="0">
+            <a:pPr marL="0" indent="0" algn="ctr">
               <a:buNone/>
             </a:pPr>
             <a:r>
@@ -4372,7 +4148,7 @@
           <a:bodyPr wrap="square" lIns="0" tIns="0" rIns="0" bIns="0" rtlCol="0" anchor="ctr"/>
           <a:lstStyle/>
           <a:p>
-            <a:pPr algn="l" indent="0" marL="0">
+            <a:pPr marL="0" indent="0" algn="l">
               <a:buNone/>
             </a:pPr>
             <a:r>
@@ -4411,7 +4187,7 @@
           <a:bodyPr wrap="square" lIns="0" tIns="0" rIns="0" bIns="0" rtlCol="0" anchor="t"/>
           <a:lstStyle/>
           <a:p>
-            <a:pPr algn="l" indent="0" marL="0">
+            <a:pPr marL="0" indent="0" algn="l">
               <a:buNone/>
             </a:pPr>
             <a:r>
@@ -4445,6 +4221,7 @@
         <a:solidFill>
           <a:srgbClr val="1A1323"/>
         </a:solidFill>
+        <a:effectLst/>
       </p:bgPr>
     </p:bg>
     <p:spTree>
@@ -4480,6 +4257,13 @@
           </a:solidFill>
           <a:ln/>
         </p:spPr>
+        <p:txBody>
+          <a:bodyPr/>
+          <a:lstStyle/>
+          <a:p>
+            <a:endParaRPr lang="fr-FR"/>
+          </a:p>
+        </p:txBody>
       </p:sp>
       <p:sp>
         <p:nvSpPr>
@@ -4502,7 +4286,7 @@
           <a:bodyPr wrap="square" lIns="0" tIns="0" rIns="0" bIns="0" rtlCol="0" anchor="ctr"/>
           <a:lstStyle/>
           <a:p>
-            <a:pPr algn="ctr" indent="0" marL="0">
+            <a:pPr marL="0" indent="0" algn="ctr">
               <a:buNone/>
             </a:pPr>
             <a:r>
@@ -4541,7 +4325,7 @@
           <a:bodyPr wrap="square" lIns="0" tIns="0" rIns="0" bIns="0" rtlCol="0" anchor="ctr"/>
           <a:lstStyle/>
           <a:p>
-            <a:pPr algn="l" indent="0" marL="0">
+            <a:pPr marL="0" indent="0" algn="l">
               <a:buNone/>
             </a:pPr>
             <a:r>
@@ -4580,7 +4364,7 @@
           <a:bodyPr wrap="square" lIns="0" tIns="0" rIns="0" bIns="0" rtlCol="0" anchor="t"/>
           <a:lstStyle/>
           <a:p>
-            <a:pPr algn="l" indent="0" marL="0">
+            <a:pPr marL="0" indent="0" algn="l">
               <a:buNone/>
             </a:pPr>
             <a:r>
@@ -4619,7 +4403,7 @@
           <a:bodyPr wrap="square" lIns="0" tIns="0" rIns="0" bIns="0" rtlCol="0" anchor="t"/>
           <a:lstStyle/>
           <a:p>
-            <a:pPr algn="l" indent="0" marL="0">
+            <a:pPr marL="0" indent="0" algn="l">
               <a:buNone/>
             </a:pPr>
             <a:r>
@@ -4653,6 +4437,7 @@
         <a:solidFill>
           <a:srgbClr val="FDF3F0"/>
         </a:solidFill>
+        <a:effectLst/>
       </p:bgPr>
     </p:bg>
     <p:spTree>
@@ -4690,7 +4475,7 @@
           <a:bodyPr wrap="square" lIns="0" tIns="0" rIns="0" bIns="0" rtlCol="0" anchor="ctr"/>
           <a:lstStyle/>
           <a:p>
-            <a:pPr algn="ctr" indent="0" marL="0">
+            <a:pPr marL="0" indent="0" algn="ctr">
               <a:buNone/>
             </a:pPr>
             <a:r>
@@ -4729,7 +4514,7 @@
           <a:bodyPr wrap="square" lIns="0" tIns="0" rIns="0" bIns="0" rtlCol="0" anchor="ctr"/>
           <a:lstStyle/>
           <a:p>
-            <a:pPr algn="ctr" indent="0" marL="0">
+            <a:pPr marL="0" indent="0" algn="ctr">
               <a:buNone/>
             </a:pPr>
             <a:r>
@@ -4768,7 +4553,7 @@
           <a:bodyPr wrap="square" lIns="0" tIns="0" rIns="0" bIns="0" rtlCol="0" anchor="ctr"/>
           <a:lstStyle/>
           <a:p>
-            <a:pPr algn="ctr" indent="0" marL="0">
+            <a:pPr marL="0" indent="0" algn="ctr">
               <a:buNone/>
             </a:pPr>
             <a:r>
@@ -4807,7 +4592,7 @@
           <a:bodyPr wrap="square" lIns="0" tIns="0" rIns="0" bIns="0" rtlCol="0" anchor="ctr"/>
           <a:lstStyle/>
           <a:p>
-            <a:pPr algn="ctr" indent="0" marL="0">
+            <a:pPr marL="0" indent="0" algn="ctr">
               <a:buNone/>
             </a:pPr>
             <a:r>
@@ -4844,6 +4629,13 @@
           </a:solidFill>
           <a:ln/>
         </p:spPr>
+        <p:txBody>
+          <a:bodyPr/>
+          <a:lstStyle/>
+          <a:p>
+            <a:endParaRPr lang="fr-FR"/>
+          </a:p>
+        </p:txBody>
       </p:sp>
       <p:sp>
         <p:nvSpPr>
@@ -4866,7 +4658,7 @@
           <a:bodyPr wrap="square" lIns="0" tIns="0" rIns="0" bIns="0" rtlCol="0" anchor="ctr"/>
           <a:lstStyle/>
           <a:p>
-            <a:pPr algn="ctr" indent="0" marL="0">
+            <a:pPr marL="0" indent="0" algn="ctr">
               <a:buNone/>
             </a:pPr>
             <a:r>
@@ -4905,7 +4697,7 @@
           <a:bodyPr wrap="square" lIns="0" tIns="0" rIns="0" bIns="0" rtlCol="0" anchor="ctr"/>
           <a:lstStyle/>
           <a:p>
-            <a:pPr algn="l" indent="0" marL="0">
+            <a:pPr marL="0" indent="0" algn="l">
               <a:buNone/>
             </a:pPr>
             <a:r>
@@ -4917,7 +4709,7 @@
                 <a:ea typeface="Arial" pitchFamily="34" charset="-122"/>
                 <a:cs typeface="Arial" pitchFamily="34" charset="-120"/>
               </a:rPr>
-              <a:t>4 outils, 4 usages</a:t>
+              <a:t>5 outils, 5 usages</a:t>
             </a:r>
             <a:endParaRPr lang="en-US" sz="2800" dirty="0"/>
           </a:p>
@@ -4944,7 +4736,7 @@
           <a:bodyPr wrap="square" lIns="0" tIns="0" rIns="0" bIns="0" rtlCol="0" anchor="t"/>
           <a:lstStyle/>
           <a:p>
-            <a:pPr algn="l" indent="0" marL="0">
+            <a:pPr marL="0" indent="0" algn="l">
               <a:buNone/>
             </a:pPr>
             <a:r>
@@ -4958,12 +4750,6 @@
               </a:rPr>
               <a:t>●  </a:t>
             </a:r>
-            <a:pPr algn="l" indent="0" marL="0">
-              <a:spcAft>
-                <a:spcPts val="1400"/>
-              </a:spcAft>
-              <a:buNone/>
-            </a:pPr>
             <a:r>
               <a:rPr lang="en-US" sz="1600" dirty="0">
                 <a:solidFill>
@@ -4978,7 +4764,7 @@
             <a:endParaRPr lang="en-US" sz="1600" dirty="0"/>
           </a:p>
           <a:p>
-            <a:pPr algn="l" indent="0" marL="0">
+            <a:pPr marL="0" indent="0" algn="l">
               <a:buNone/>
             </a:pPr>
             <a:r>
@@ -4992,12 +4778,6 @@
               </a:rPr>
               <a:t>●  </a:t>
             </a:r>
-            <a:pPr algn="l" indent="0" marL="0">
-              <a:spcAft>
-                <a:spcPts val="1400"/>
-              </a:spcAft>
-              <a:buNone/>
-            </a:pPr>
             <a:r>
               <a:rPr lang="en-US" sz="1600" dirty="0">
                 <a:solidFill>
@@ -5012,7 +4792,7 @@
             <a:endParaRPr lang="en-US" sz="1600" dirty="0"/>
           </a:p>
           <a:p>
-            <a:pPr algn="l" indent="0" marL="0">
+            <a:pPr marL="0" indent="0" algn="l">
               <a:buNone/>
             </a:pPr>
             <a:r>
@@ -5026,12 +4806,6 @@
               </a:rPr>
               <a:t>●  </a:t>
             </a:r>
-            <a:pPr algn="l" indent="0" marL="0">
-              <a:spcAft>
-                <a:spcPts val="1400"/>
-              </a:spcAft>
-              <a:buNone/>
-            </a:pPr>
             <a:r>
               <a:rPr lang="en-US" sz="1600" dirty="0">
                 <a:solidFill>
@@ -5043,10 +4817,42 @@
               </a:rPr>
               <a:t>Claude Cowork — pour un projet suivi dans le temps</a:t>
             </a:r>
+            <a:endParaRPr lang="en-US" sz="1600" dirty="0">
+              <a:solidFill>
+                <a:srgbClr val="E06840"/>
+              </a:solidFill>
+              <a:latin typeface="Arial" pitchFamily="34" charset="0"/>
+              <a:ea typeface="Arial" pitchFamily="34" charset="-122"/>
+              <a:cs typeface="Arial" pitchFamily="34" charset="-120"/>
+            </a:endParaRPr>
+          </a:p>
+          <a:p>
+            <a:r>
+              <a:rPr lang="en-US" sz="1600" dirty="0">
+                <a:solidFill>
+                  <a:srgbClr val="E06840"/>
+                </a:solidFill>
+                <a:latin typeface="Arial" pitchFamily="34" charset="0"/>
+                <a:ea typeface="Arial" pitchFamily="34" charset="-122"/>
+                <a:cs typeface="Arial" pitchFamily="34" charset="-120"/>
+              </a:rPr>
+              <a:t>●  </a:t>
+            </a:r>
+            <a:r>
+              <a:rPr lang="en-US" sz="1600" dirty="0">
+                <a:solidFill>
+                  <a:srgbClr val="1A1323"/>
+                </a:solidFill>
+                <a:latin typeface="Arial" pitchFamily="34" charset="0"/>
+                <a:ea typeface="Arial" pitchFamily="34" charset="-122"/>
+                <a:cs typeface="Arial" pitchFamily="34" charset="-120"/>
+              </a:rPr>
+              <a:t>Claude Design — pour des designs (presentations, wireframe, …)</a:t>
+            </a:r>
             <a:endParaRPr lang="en-US" sz="1600" dirty="0"/>
           </a:p>
           <a:p>
-            <a:pPr algn="l" indent="0" marL="0">
+            <a:pPr marL="0" indent="0" algn="l">
               <a:buNone/>
             </a:pPr>
             <a:r>
@@ -5060,9 +4866,6 @@
               </a:rPr>
               <a:t>●  </a:t>
             </a:r>
-            <a:pPr algn="l" indent="0" marL="0">
-              <a:buNone/>
-            </a:pPr>
             <a:r>
               <a:rPr lang="en-US" sz="1600" dirty="0">
                 <a:solidFill>
@@ -5074,6 +4877,11 @@
               </a:rPr>
               <a:t>Claude in Chrome — pour le web</a:t>
             </a:r>
+          </a:p>
+          <a:p>
+            <a:pPr marL="0" indent="0" algn="l">
+              <a:buNone/>
+            </a:pPr>
             <a:endParaRPr lang="en-US" sz="1600" dirty="0"/>
           </a:p>
         </p:txBody>
@@ -5099,6 +4907,13 @@
           </a:solidFill>
           <a:ln/>
         </p:spPr>
+        <p:txBody>
+          <a:bodyPr/>
+          <a:lstStyle/>
+          <a:p>
+            <a:endParaRPr lang="fr-FR"/>
+          </a:p>
+        </p:txBody>
       </p:sp>
       <p:sp>
         <p:nvSpPr>
@@ -5121,7 +4936,7 @@
           <a:bodyPr wrap="square" lIns="0" tIns="0" rIns="0" bIns="0" rtlCol="0" anchor="ctr"/>
           <a:lstStyle/>
           <a:p>
-            <a:pPr algn="l" indent="0" marL="0">
+            <a:pPr marL="0" indent="0" algn="l">
               <a:buNone/>
             </a:pPr>
             <a:r>
@@ -5160,7 +4975,7 @@
           <a:bodyPr wrap="square" lIns="0" tIns="0" rIns="0" bIns="0" rtlCol="0" anchor="t"/>
           <a:lstStyle/>
           <a:p>
-            <a:pPr algn="l" indent="0" marL="0">
+            <a:pPr marL="0" indent="0" algn="l">
               <a:buNone/>
             </a:pPr>
             <a:r>
@@ -5174,9 +4989,6 @@
               </a:rPr>
               <a:t>●  </a:t>
             </a:r>
-            <a:pPr algn="l" indent="0" marL="0">
-              <a:buNone/>
-            </a:pPr>
             <a:r>
               <a:rPr lang="en-US" sz="1500" dirty="0">
                 <a:solidFill>
@@ -5208,6 +5020,7 @@
         <a:solidFill>
           <a:srgbClr val="FDF3F0"/>
         </a:solidFill>
+        <a:effectLst/>
       </p:bgPr>
     </p:bg>
     <p:spTree>
@@ -5245,7 +5058,7 @@
           <a:bodyPr wrap="square" lIns="0" tIns="0" rIns="0" bIns="0" rtlCol="0" anchor="ctr"/>
           <a:lstStyle/>
           <a:p>
-            <a:pPr algn="ctr" indent="0" marL="0">
+            <a:pPr marL="0" indent="0" algn="ctr">
               <a:buNone/>
             </a:pPr>
             <a:r>
@@ -5284,7 +5097,7 @@
           <a:bodyPr wrap="square" lIns="0" tIns="0" rIns="0" bIns="0" rtlCol="0" anchor="ctr"/>
           <a:lstStyle/>
           <a:p>
-            <a:pPr algn="ctr" indent="0" marL="0">
+            <a:pPr marL="0" indent="0" algn="ctr">
               <a:buNone/>
             </a:pPr>
             <a:r>
@@ -5323,7 +5136,7 @@
           <a:bodyPr wrap="square" lIns="0" tIns="0" rIns="0" bIns="0" rtlCol="0" anchor="ctr"/>
           <a:lstStyle/>
           <a:p>
-            <a:pPr algn="ctr" indent="0" marL="0">
+            <a:pPr marL="0" indent="0" algn="ctr">
               <a:buNone/>
             </a:pPr>
             <a:r>
@@ -5362,7 +5175,7 @@
           <a:bodyPr wrap="square" lIns="0" tIns="0" rIns="0" bIns="0" rtlCol="0" anchor="ctr"/>
           <a:lstStyle/>
           <a:p>
-            <a:pPr algn="ctr" indent="0" marL="0">
+            <a:pPr marL="0" indent="0" algn="ctr">
               <a:buNone/>
             </a:pPr>
             <a:r>
@@ -5399,6 +5212,13 @@
           </a:solidFill>
           <a:ln/>
         </p:spPr>
+        <p:txBody>
+          <a:bodyPr/>
+          <a:lstStyle/>
+          <a:p>
+            <a:endParaRPr lang="fr-FR"/>
+          </a:p>
+        </p:txBody>
       </p:sp>
       <p:sp>
         <p:nvSpPr>
@@ -5421,7 +5241,7 @@
           <a:bodyPr wrap="square" lIns="0" tIns="0" rIns="0" bIns="0" rtlCol="0" anchor="ctr"/>
           <a:lstStyle/>
           <a:p>
-            <a:pPr algn="ctr" indent="0" marL="0">
+            <a:pPr marL="0" indent="0" algn="ctr">
               <a:buNone/>
             </a:pPr>
             <a:r>
@@ -5460,7 +5280,7 @@
           <a:bodyPr wrap="square" lIns="0" tIns="0" rIns="0" bIns="0" rtlCol="0" anchor="ctr"/>
           <a:lstStyle/>
           <a:p>
-            <a:pPr algn="l" indent="0" marL="0">
+            <a:pPr marL="0" indent="0" algn="l">
               <a:buNone/>
             </a:pPr>
             <a:r>
@@ -5499,7 +5319,7 @@
           <a:bodyPr wrap="square" lIns="0" tIns="0" rIns="0" bIns="0" rtlCol="0" anchor="t"/>
           <a:lstStyle/>
           <a:p>
-            <a:pPr algn="l" indent="0" marL="0">
+            <a:pPr marL="0" indent="0" algn="l">
               <a:buNone/>
             </a:pPr>
             <a:r>
@@ -5513,12 +5333,6 @@
               </a:rPr>
               <a:t>●  </a:t>
             </a:r>
-            <a:pPr algn="l" indent="0" marL="0">
-              <a:spcAft>
-                <a:spcPts val="1400"/>
-              </a:spcAft>
-              <a:buNone/>
-            </a:pPr>
             <a:r>
               <a:rPr lang="en-US" sz="1500" dirty="0">
                 <a:solidFill>
@@ -5533,7 +5347,7 @@
             <a:endParaRPr lang="en-US" sz="1500" dirty="0"/>
           </a:p>
           <a:p>
-            <a:pPr algn="l" indent="0" marL="0">
+            <a:pPr marL="0" indent="0" algn="l">
               <a:buNone/>
             </a:pPr>
             <a:r>
@@ -5547,12 +5361,6 @@
               </a:rPr>
               <a:t>●  </a:t>
             </a:r>
-            <a:pPr algn="l" indent="0" marL="0">
-              <a:spcAft>
-                <a:spcPts val="1400"/>
-              </a:spcAft>
-              <a:buNone/>
-            </a:pPr>
             <a:r>
               <a:rPr lang="en-US" sz="1500" dirty="0">
                 <a:solidFill>
@@ -5567,7 +5375,7 @@
             <a:endParaRPr lang="en-US" sz="1500" dirty="0"/>
           </a:p>
           <a:p>
-            <a:pPr algn="l" indent="0" marL="0">
+            <a:pPr marL="0" indent="0" algn="l">
               <a:buNone/>
             </a:pPr>
             <a:r>
@@ -5581,12 +5389,6 @@
               </a:rPr>
               <a:t>●  </a:t>
             </a:r>
-            <a:pPr algn="l" indent="0" marL="0">
-              <a:spcAft>
-                <a:spcPts val="1400"/>
-              </a:spcAft>
-              <a:buNone/>
-            </a:pPr>
             <a:r>
               <a:rPr lang="en-US" sz="1500" dirty="0">
                 <a:solidFill>
@@ -5601,7 +5403,7 @@
             <a:endParaRPr lang="en-US" sz="1500" dirty="0"/>
           </a:p>
           <a:p>
-            <a:pPr algn="l" indent="0" marL="0">
+            <a:pPr marL="0" indent="0" algn="l">
               <a:buNone/>
             </a:pPr>
             <a:r>
@@ -5615,12 +5417,6 @@
               </a:rPr>
               <a:t>●  </a:t>
             </a:r>
-            <a:pPr algn="l" indent="0" marL="0">
-              <a:spcAft>
-                <a:spcPts val="1400"/>
-              </a:spcAft>
-              <a:buNone/>
-            </a:pPr>
             <a:r>
               <a:rPr lang="en-US" sz="1500" dirty="0">
                 <a:solidFill>
@@ -5635,7 +5431,7 @@
             <a:endParaRPr lang="en-US" sz="1500" dirty="0"/>
           </a:p>
           <a:p>
-            <a:pPr algn="l" indent="0" marL="0">
+            <a:pPr marL="0" indent="0" algn="l">
               <a:buNone/>
             </a:pPr>
             <a:r>
@@ -5649,9 +5445,34 @@
               </a:rPr>
               <a:t>●  </a:t>
             </a:r>
-            <a:pPr algn="l" indent="0" marL="0">
-              <a:buNone/>
-            </a:pPr>
+            <a:r>
+              <a:rPr lang="en-US" sz="1500" dirty="0">
+                <a:solidFill>
+                  <a:srgbClr val="1A1323"/>
+                </a:solidFill>
+                <a:latin typeface="Arial" pitchFamily="34" charset="0"/>
+                <a:ea typeface="Arial" pitchFamily="34" charset="-122"/>
+                <a:cs typeface="Arial" pitchFamily="34" charset="-120"/>
+              </a:rPr>
+              <a:t>Rendu visuel pro (maquette, page, support) → Claude Design</a:t>
+            </a:r>
+            <a:endParaRPr lang="en-US" sz="1500" dirty="0"/>
+          </a:p>
+          <a:p>
+            <a:pPr marL="0" indent="0" algn="l">
+              <a:buNone/>
+            </a:pPr>
+            <a:r>
+              <a:rPr lang="en-US" sz="1500" dirty="0">
+                <a:solidFill>
+                  <a:srgbClr val="E06840"/>
+                </a:solidFill>
+                <a:latin typeface="Arial" pitchFamily="34" charset="0"/>
+                <a:ea typeface="Arial" pitchFamily="34" charset="-122"/>
+                <a:cs typeface="Arial" pitchFamily="34" charset="-120"/>
+              </a:rPr>
+              <a:t>●  </a:t>
+            </a:r>
             <a:r>
               <a:rPr lang="en-US" sz="1500" dirty="0">
                 <a:solidFill>
@@ -5688,6 +5509,13 @@
           </a:solidFill>
           <a:ln/>
         </p:spPr>
+        <p:txBody>
+          <a:bodyPr/>
+          <a:lstStyle/>
+          <a:p>
+            <a:endParaRPr lang="fr-FR"/>
+          </a:p>
+        </p:txBody>
       </p:sp>
       <p:sp>
         <p:nvSpPr>
@@ -5710,7 +5538,7 @@
           <a:bodyPr wrap="square" lIns="0" tIns="0" rIns="0" bIns="0" rtlCol="0" anchor="ctr"/>
           <a:lstStyle/>
           <a:p>
-            <a:pPr algn="l" indent="0" marL="0">
+            <a:pPr marL="0" indent="0" algn="l">
               <a:buNone/>
             </a:pPr>
             <a:r>
@@ -5749,7 +5577,7 @@
           <a:bodyPr wrap="square" lIns="0" tIns="0" rIns="0" bIns="0" rtlCol="0" anchor="t"/>
           <a:lstStyle/>
           <a:p>
-            <a:pPr algn="l" indent="0" marL="0">
+            <a:pPr marL="0" indent="0" algn="l">
               <a:buNone/>
             </a:pPr>
             <a:r>
@@ -5763,9 +5591,6 @@
               </a:rPr>
               <a:t>●  </a:t>
             </a:r>
-            <a:pPr algn="l" indent="0" marL="0">
-              <a:buNone/>
-            </a:pPr>
             <a:r>
               <a:rPr lang="en-US" sz="1500" dirty="0">
                 <a:solidFill>
@@ -5797,6 +5622,7 @@
         <a:solidFill>
           <a:srgbClr val="1A1323"/>
         </a:solidFill>
+        <a:effectLst/>
       </p:bgPr>
     </p:bg>
     <p:spTree>
@@ -5832,6 +5658,13 @@
           </a:solidFill>
           <a:ln/>
         </p:spPr>
+        <p:txBody>
+          <a:bodyPr/>
+          <a:lstStyle/>
+          <a:p>
+            <a:endParaRPr lang="fr-FR"/>
+          </a:p>
+        </p:txBody>
       </p:sp>
       <p:sp>
         <p:nvSpPr>
@@ -5854,7 +5687,7 @@
           <a:bodyPr wrap="square" lIns="0" tIns="0" rIns="0" bIns="0" rtlCol="0" anchor="ctr"/>
           <a:lstStyle/>
           <a:p>
-            <a:pPr algn="ctr" indent="0" marL="0">
+            <a:pPr marL="0" indent="0" algn="ctr">
               <a:buNone/>
             </a:pPr>
             <a:r>
@@ -5893,7 +5726,7 @@
           <a:bodyPr wrap="square" lIns="0" tIns="0" rIns="0" bIns="0" rtlCol="0" anchor="t"/>
           <a:lstStyle/>
           <a:p>
-            <a:pPr algn="l" indent="0" marL="0">
+            <a:pPr marL="0" indent="0" algn="l">
               <a:buNone/>
             </a:pPr>
             <a:r>
@@ -5932,7 +5765,7 @@
           <a:bodyPr wrap="square" lIns="0" tIns="0" rIns="0" bIns="0" rtlCol="0" anchor="ctr"/>
           <a:lstStyle/>
           <a:p>
-            <a:pPr algn="l" indent="0" marL="0">
+            <a:pPr marL="0" indent="0" algn="l">
               <a:buNone/>
             </a:pPr>
             <a:r>
@@ -5966,6 +5799,7 @@
         <a:solidFill>
           <a:srgbClr val="1A1323"/>
         </a:solidFill>
+        <a:effectLst/>
       </p:bgPr>
     </p:bg>
     <p:spTree>
@@ -6001,6 +5835,13 @@
           </a:solidFill>
           <a:ln/>
         </p:spPr>
+        <p:txBody>
+          <a:bodyPr/>
+          <a:lstStyle/>
+          <a:p>
+            <a:endParaRPr lang="fr-FR"/>
+          </a:p>
+        </p:txBody>
       </p:sp>
       <p:sp>
         <p:nvSpPr>
@@ -6023,7 +5864,7 @@
           <a:bodyPr wrap="square" lIns="0" tIns="0" rIns="0" bIns="0" rtlCol="0" anchor="ctr"/>
           <a:lstStyle/>
           <a:p>
-            <a:pPr algn="ctr" indent="0" marL="0">
+            <a:pPr marL="0" indent="0" algn="ctr">
               <a:buNone/>
             </a:pPr>
             <a:r>
@@ -6062,7 +5903,7 @@
           <a:bodyPr wrap="square" lIns="0" tIns="0" rIns="0" bIns="0" rtlCol="0" anchor="ctr"/>
           <a:lstStyle/>
           <a:p>
-            <a:pPr algn="l" indent="0" marL="0">
+            <a:pPr marL="0" indent="0" algn="l">
               <a:buNone/>
             </a:pPr>
             <a:r>
@@ -6101,7 +5942,7 @@
           <a:bodyPr wrap="square" lIns="0" tIns="0" rIns="0" bIns="0" rtlCol="0" anchor="t"/>
           <a:lstStyle/>
           <a:p>
-            <a:pPr algn="l" indent="0" marL="0">
+            <a:pPr marL="0" indent="0" algn="l">
               <a:buNone/>
             </a:pPr>
             <a:r>
@@ -6140,7 +5981,7 @@
           <a:bodyPr wrap="square" lIns="0" tIns="0" rIns="0" bIns="0" rtlCol="0" anchor="t"/>
           <a:lstStyle/>
           <a:p>
-            <a:pPr algn="l" indent="0" marL="0">
+            <a:pPr marL="0" indent="0" algn="l">
               <a:buNone/>
             </a:pPr>
             <a:r>
@@ -6174,6 +6015,7 @@
         <a:solidFill>
           <a:srgbClr val="FDF3F0"/>
         </a:solidFill>
+        <a:effectLst/>
       </p:bgPr>
     </p:bg>
     <p:spTree>
@@ -6211,7 +6053,7 @@
           <a:bodyPr wrap="square" lIns="0" tIns="0" rIns="0" bIns="0" rtlCol="0" anchor="ctr"/>
           <a:lstStyle/>
           <a:p>
-            <a:pPr algn="ctr" indent="0" marL="0">
+            <a:pPr marL="0" indent="0" algn="ctr">
               <a:buNone/>
             </a:pPr>
             <a:r>
@@ -6250,7 +6092,7 @@
           <a:bodyPr wrap="square" lIns="0" tIns="0" rIns="0" bIns="0" rtlCol="0" anchor="ctr"/>
           <a:lstStyle/>
           <a:p>
-            <a:pPr algn="ctr" indent="0" marL="0">
+            <a:pPr marL="0" indent="0" algn="ctr">
               <a:buNone/>
             </a:pPr>
             <a:r>
@@ -6289,7 +6131,7 @@
           <a:bodyPr wrap="square" lIns="0" tIns="0" rIns="0" bIns="0" rtlCol="0" anchor="ctr"/>
           <a:lstStyle/>
           <a:p>
-            <a:pPr algn="ctr" indent="0" marL="0">
+            <a:pPr marL="0" indent="0" algn="ctr">
               <a:buNone/>
             </a:pPr>
             <a:r>
@@ -6328,7 +6170,7 @@
           <a:bodyPr wrap="square" lIns="0" tIns="0" rIns="0" bIns="0" rtlCol="0" anchor="ctr"/>
           <a:lstStyle/>
           <a:p>
-            <a:pPr algn="ctr" indent="0" marL="0">
+            <a:pPr marL="0" indent="0" algn="ctr">
               <a:buNone/>
             </a:pPr>
             <a:r>
@@ -6365,6 +6207,13 @@
           </a:solidFill>
           <a:ln/>
         </p:spPr>
+        <p:txBody>
+          <a:bodyPr/>
+          <a:lstStyle/>
+          <a:p>
+            <a:endParaRPr lang="fr-FR"/>
+          </a:p>
+        </p:txBody>
       </p:sp>
       <p:sp>
         <p:nvSpPr>
@@ -6387,7 +6236,7 @@
           <a:bodyPr wrap="square" lIns="0" tIns="0" rIns="0" bIns="0" rtlCol="0" anchor="ctr"/>
           <a:lstStyle/>
           <a:p>
-            <a:pPr algn="ctr" indent="0" marL="0">
+            <a:pPr marL="0" indent="0" algn="ctr">
               <a:buNone/>
             </a:pPr>
             <a:r>
@@ -6426,7 +6275,7 @@
           <a:bodyPr wrap="square" lIns="0" tIns="0" rIns="0" bIns="0" rtlCol="0" anchor="ctr"/>
           <a:lstStyle/>
           <a:p>
-            <a:pPr algn="l" indent="0" marL="0">
+            <a:pPr marL="0" indent="0" algn="l">
               <a:buNone/>
             </a:pPr>
             <a:r>
@@ -6465,7 +6314,7 @@
           <a:bodyPr wrap="square" lIns="0" tIns="0" rIns="0" bIns="0" rtlCol="0" anchor="t"/>
           <a:lstStyle/>
           <a:p>
-            <a:pPr algn="l" indent="0" marL="0">
+            <a:pPr marL="0" indent="0" algn="l">
               <a:buNone/>
             </a:pPr>
             <a:r>
@@ -6479,12 +6328,6 @@
               </a:rPr>
               <a:t>●  </a:t>
             </a:r>
-            <a:pPr algn="l" indent="0" marL="0">
-              <a:spcAft>
-                <a:spcPts val="1400"/>
-              </a:spcAft>
-              <a:buNone/>
-            </a:pPr>
             <a:r>
               <a:rPr lang="en-US" sz="1500" dirty="0">
                 <a:solidFill>
@@ -6499,7 +6342,7 @@
             <a:endParaRPr lang="en-US" sz="1500" dirty="0"/>
           </a:p>
           <a:p>
-            <a:pPr algn="l" indent="0" marL="0">
+            <a:pPr marL="0" indent="0" algn="l">
               <a:buNone/>
             </a:pPr>
             <a:r>
@@ -6513,12 +6356,6 @@
               </a:rPr>
               <a:t>●  </a:t>
             </a:r>
-            <a:pPr algn="l" indent="0" marL="0">
-              <a:spcAft>
-                <a:spcPts val="1400"/>
-              </a:spcAft>
-              <a:buNone/>
-            </a:pPr>
             <a:r>
               <a:rPr lang="en-US" sz="1500" dirty="0">
                 <a:solidFill>
@@ -6533,7 +6370,7 @@
             <a:endParaRPr lang="en-US" sz="1500" dirty="0"/>
           </a:p>
           <a:p>
-            <a:pPr algn="l" indent="0" marL="0">
+            <a:pPr marL="0" indent="0" algn="l">
               <a:buNone/>
             </a:pPr>
             <a:r>
@@ -6547,9 +6384,6 @@
               </a:rPr>
               <a:t>●  </a:t>
             </a:r>
-            <a:pPr algn="l" indent="0" marL="0">
-              <a:buNone/>
-            </a:pPr>
             <a:r>
               <a:rPr lang="en-US" sz="1500" dirty="0">
                 <a:solidFill>
@@ -6586,6 +6420,13 @@
           </a:solidFill>
           <a:ln/>
         </p:spPr>
+        <p:txBody>
+          <a:bodyPr/>
+          <a:lstStyle/>
+          <a:p>
+            <a:endParaRPr lang="fr-FR"/>
+          </a:p>
+        </p:txBody>
       </p:sp>
       <p:sp>
         <p:nvSpPr>
@@ -6608,7 +6449,7 @@
           <a:bodyPr wrap="square" lIns="0" tIns="0" rIns="0" bIns="0" rtlCol="0" anchor="ctr"/>
           <a:lstStyle/>
           <a:p>
-            <a:pPr algn="l" indent="0" marL="0">
+            <a:pPr marL="0" indent="0" algn="l">
               <a:buNone/>
             </a:pPr>
             <a:r>
@@ -6647,7 +6488,7 @@
           <a:bodyPr wrap="square" lIns="0" tIns="0" rIns="0" bIns="0" rtlCol="0" anchor="t"/>
           <a:lstStyle/>
           <a:p>
-            <a:pPr algn="l" indent="0" marL="0">
+            <a:pPr marL="0" indent="0" algn="l">
               <a:buNone/>
             </a:pPr>
             <a:r>
@@ -6661,9 +6502,6 @@
               </a:rPr>
               <a:t>●  </a:t>
             </a:r>
-            <a:pPr algn="l" indent="0" marL="0">
-              <a:buNone/>
-            </a:pPr>
             <a:r>
               <a:rPr lang="en-US" sz="1500" dirty="0">
                 <a:solidFill>
@@ -6695,6 +6533,7 @@
         <a:solidFill>
           <a:srgbClr val="1A1323"/>
         </a:solidFill>
+        <a:effectLst/>
       </p:bgPr>
     </p:bg>
     <p:spTree>
@@ -6730,6 +6569,13 @@
           </a:solidFill>
           <a:ln/>
         </p:spPr>
+        <p:txBody>
+          <a:bodyPr/>
+          <a:lstStyle/>
+          <a:p>
+            <a:endParaRPr lang="fr-FR"/>
+          </a:p>
+        </p:txBody>
       </p:sp>
       <p:sp>
         <p:nvSpPr>
@@ -6752,7 +6598,7 @@
           <a:bodyPr wrap="square" lIns="0" tIns="0" rIns="0" bIns="0" rtlCol="0" anchor="ctr"/>
           <a:lstStyle/>
           <a:p>
-            <a:pPr algn="ctr" indent="0" marL="0">
+            <a:pPr marL="0" indent="0" algn="ctr">
               <a:buNone/>
             </a:pPr>
             <a:r>
@@ -6791,7 +6637,7 @@
           <a:bodyPr wrap="square" lIns="0" tIns="0" rIns="0" bIns="0" rtlCol="0" anchor="ctr"/>
           <a:lstStyle/>
           <a:p>
-            <a:pPr algn="l" indent="0" marL="0">
+            <a:pPr marL="0" indent="0" algn="l">
               <a:buNone/>
             </a:pPr>
             <a:r>
@@ -6830,7 +6676,7 @@
           <a:bodyPr wrap="square" lIns="0" tIns="0" rIns="0" bIns="0" rtlCol="0" anchor="t"/>
           <a:lstStyle/>
           <a:p>
-            <a:pPr algn="l" indent="0" marL="0">
+            <a:pPr marL="0" indent="0" algn="l">
               <a:buNone/>
             </a:pPr>
             <a:r>
@@ -6869,7 +6715,7 @@
           <a:bodyPr wrap="square" lIns="0" tIns="0" rIns="0" bIns="0" rtlCol="0" anchor="t"/>
           <a:lstStyle/>
           <a:p>
-            <a:pPr algn="l" indent="0" marL="0">
+            <a:pPr marL="0" indent="0" algn="l">
               <a:buNone/>
             </a:pPr>
             <a:r>
@@ -6903,6 +6749,7 @@
         <a:solidFill>
           <a:srgbClr val="FDF3F0"/>
         </a:solidFill>
+        <a:effectLst/>
       </p:bgPr>
     </p:bg>
     <p:spTree>
@@ -6940,7 +6787,7 @@
           <a:bodyPr wrap="square" lIns="0" tIns="0" rIns="0" bIns="0" rtlCol="0" anchor="ctr"/>
           <a:lstStyle/>
           <a:p>
-            <a:pPr algn="ctr" indent="0" marL="0">
+            <a:pPr marL="0" indent="0" algn="ctr">
               <a:buNone/>
             </a:pPr>
             <a:r>
@@ -6979,7 +6826,7 @@
           <a:bodyPr wrap="square" lIns="0" tIns="0" rIns="0" bIns="0" rtlCol="0" anchor="ctr"/>
           <a:lstStyle/>
           <a:p>
-            <a:pPr algn="ctr" indent="0" marL="0">
+            <a:pPr marL="0" indent="0" algn="ctr">
               <a:buNone/>
             </a:pPr>
             <a:r>
@@ -7018,7 +6865,7 @@
           <a:bodyPr wrap="square" lIns="0" tIns="0" rIns="0" bIns="0" rtlCol="0" anchor="ctr"/>
           <a:lstStyle/>
           <a:p>
-            <a:pPr algn="ctr" indent="0" marL="0">
+            <a:pPr marL="0" indent="0" algn="ctr">
               <a:buNone/>
             </a:pPr>
             <a:r>
@@ -7057,7 +6904,7 @@
           <a:bodyPr wrap="square" lIns="0" tIns="0" rIns="0" bIns="0" rtlCol="0" anchor="ctr"/>
           <a:lstStyle/>
           <a:p>
-            <a:pPr algn="ctr" indent="0" marL="0">
+            <a:pPr marL="0" indent="0" algn="ctr">
               <a:buNone/>
             </a:pPr>
             <a:r>
@@ -7094,6 +6941,13 @@
           </a:solidFill>
           <a:ln/>
         </p:spPr>
+        <p:txBody>
+          <a:bodyPr/>
+          <a:lstStyle/>
+          <a:p>
+            <a:endParaRPr lang="fr-FR"/>
+          </a:p>
+        </p:txBody>
       </p:sp>
       <p:sp>
         <p:nvSpPr>
@@ -7116,7 +6970,7 @@
           <a:bodyPr wrap="square" lIns="0" tIns="0" rIns="0" bIns="0" rtlCol="0" anchor="ctr"/>
           <a:lstStyle/>
           <a:p>
-            <a:pPr algn="ctr" indent="0" marL="0">
+            <a:pPr marL="0" indent="0" algn="ctr">
               <a:buNone/>
             </a:pPr>
             <a:r>
@@ -7155,7 +7009,7 @@
           <a:bodyPr wrap="square" lIns="0" tIns="0" rIns="0" bIns="0" rtlCol="0" anchor="ctr"/>
           <a:lstStyle/>
           <a:p>
-            <a:pPr algn="l" indent="0" marL="0">
+            <a:pPr marL="0" indent="0" algn="l">
               <a:buNone/>
             </a:pPr>
             <a:r>
@@ -7194,7 +7048,7 @@
           <a:bodyPr wrap="square" lIns="0" tIns="0" rIns="0" bIns="0" rtlCol="0" anchor="t"/>
           <a:lstStyle/>
           <a:p>
-            <a:pPr algn="l" indent="0" marL="0">
+            <a:pPr marL="0" indent="0" algn="l">
               <a:lnSpc>
                 <a:spcPct val="125000"/>
               </a:lnSpc>
@@ -7214,7 +7068,7 @@
             <a:endParaRPr lang="en-US" sz="1250" dirty="0"/>
           </a:p>
           <a:p>
-            <a:pPr algn="l" indent="0" marL="0">
+            <a:pPr marL="0" indent="0" algn="l">
               <a:lnSpc>
                 <a:spcPct val="125000"/>
               </a:lnSpc>
@@ -7234,7 +7088,7 @@
             <a:endParaRPr lang="en-US" sz="1250" dirty="0"/>
           </a:p>
           <a:p>
-            <a:pPr algn="l" indent="0" marL="0">
+            <a:pPr marL="0" indent="0" algn="l">
               <a:lnSpc>
                 <a:spcPct val="125000"/>
               </a:lnSpc>
@@ -7254,7 +7108,7 @@
             <a:endParaRPr lang="en-US" sz="1250" dirty="0"/>
           </a:p>
           <a:p>
-            <a:pPr algn="l" indent="0" marL="0">
+            <a:pPr marL="0" indent="0" algn="l">
               <a:lnSpc>
                 <a:spcPct val="125000"/>
               </a:lnSpc>
@@ -7274,7 +7128,7 @@
             <a:endParaRPr lang="en-US" sz="1250" dirty="0"/>
           </a:p>
           <a:p>
-            <a:pPr algn="l" indent="0" marL="0">
+            <a:pPr marL="0" indent="0" algn="l">
               <a:lnSpc>
                 <a:spcPct val="125000"/>
               </a:lnSpc>
@@ -7294,7 +7148,7 @@
             <a:endParaRPr lang="en-US" sz="1250" dirty="0"/>
           </a:p>
           <a:p>
-            <a:pPr algn="l" indent="0" marL="0">
+            <a:pPr marL="0" indent="0" algn="l">
               <a:lnSpc>
                 <a:spcPct val="125000"/>
               </a:lnSpc>
@@ -7314,7 +7168,7 @@
             <a:endParaRPr lang="en-US" sz="1250" dirty="0"/>
           </a:p>
           <a:p>
-            <a:pPr algn="l" indent="0" marL="0">
+            <a:pPr marL="0" indent="0" algn="l">
               <a:lnSpc>
                 <a:spcPct val="125000"/>
               </a:lnSpc>
@@ -7323,7 +7177,7 @@
             <a:endParaRPr lang="en-US" sz="1250" dirty="0"/>
           </a:p>
           <a:p>
-            <a:pPr algn="l" indent="0" marL="0">
+            <a:pPr marL="0" indent="0" algn="l">
               <a:lnSpc>
                 <a:spcPct val="125000"/>
               </a:lnSpc>
@@ -7343,7 +7197,7 @@
             <a:endParaRPr lang="en-US" sz="1250" dirty="0"/>
           </a:p>
           <a:p>
-            <a:pPr algn="l" indent="0" marL="0">
+            <a:pPr marL="0" indent="0" algn="l">
               <a:lnSpc>
                 <a:spcPct val="125000"/>
               </a:lnSpc>
@@ -7363,7 +7217,7 @@
             <a:endParaRPr lang="en-US" sz="1250" dirty="0"/>
           </a:p>
           <a:p>
-            <a:pPr algn="l" indent="0" marL="0">
+            <a:pPr marL="0" indent="0" algn="l">
               <a:lnSpc>
                 <a:spcPct val="125000"/>
               </a:lnSpc>
@@ -7405,6 +7259,13 @@
           </a:solidFill>
           <a:ln/>
         </p:spPr>
+        <p:txBody>
+          <a:bodyPr/>
+          <a:lstStyle/>
+          <a:p>
+            <a:endParaRPr lang="fr-FR"/>
+          </a:p>
+        </p:txBody>
       </p:sp>
       <p:sp>
         <p:nvSpPr>
@@ -7427,7 +7288,7 @@
           <a:bodyPr wrap="square" lIns="0" tIns="0" rIns="0" bIns="0" rtlCol="0" anchor="ctr"/>
           <a:lstStyle/>
           <a:p>
-            <a:pPr algn="l" indent="0" marL="0">
+            <a:pPr marL="0" indent="0" algn="l">
               <a:buNone/>
             </a:pPr>
             <a:r>
@@ -7466,7 +7327,7 @@
           <a:bodyPr wrap="square" lIns="0" tIns="0" rIns="0" bIns="0" rtlCol="0" anchor="t"/>
           <a:lstStyle/>
           <a:p>
-            <a:pPr algn="l" indent="0" marL="0">
+            <a:pPr marL="0" indent="0" algn="l">
               <a:buNone/>
             </a:pPr>
             <a:r>
@@ -7480,9 +7341,6 @@
               </a:rPr>
               <a:t>●  </a:t>
             </a:r>
-            <a:pPr algn="l" indent="0" marL="0">
-              <a:buNone/>
-            </a:pPr>
             <a:r>
               <a:rPr lang="en-US" sz="1500" dirty="0">
                 <a:solidFill>
@@ -7799,4 +7657,319 @@
     </a:ext>
   </a:extLst>
 </a:theme>
+</file>
+
+<file path=ppt/theme/theme2.xml><?xml version="1.0" encoding="utf-8"?>
+<a:theme xmlns:a="http://schemas.openxmlformats.org/drawingml/2006/main" name="Thème Office">
+  <a:themeElements>
+    <a:clrScheme name="Office">
+      <a:dk1>
+        <a:sysClr val="windowText" lastClr="000000"/>
+      </a:dk1>
+      <a:lt1>
+        <a:sysClr val="window" lastClr="FFFFFF"/>
+      </a:lt1>
+      <a:dk2>
+        <a:srgbClr val="0E2841"/>
+      </a:dk2>
+      <a:lt2>
+        <a:srgbClr val="E8E8E8"/>
+      </a:lt2>
+      <a:accent1>
+        <a:srgbClr val="156082"/>
+      </a:accent1>
+      <a:accent2>
+        <a:srgbClr val="E97132"/>
+      </a:accent2>
+      <a:accent3>
+        <a:srgbClr val="196B24"/>
+      </a:accent3>
+      <a:accent4>
+        <a:srgbClr val="0F9ED5"/>
+      </a:accent4>
+      <a:accent5>
+        <a:srgbClr val="A02B93"/>
+      </a:accent5>
+      <a:accent6>
+        <a:srgbClr val="4EA72E"/>
+      </a:accent6>
+      <a:hlink>
+        <a:srgbClr val="467886"/>
+      </a:hlink>
+      <a:folHlink>
+        <a:srgbClr val="96607D"/>
+      </a:folHlink>
+    </a:clrScheme>
+    <a:fontScheme name="Office">
+      <a:majorFont>
+        <a:latin typeface="Aptos Display" panose="02110004020202020204"/>
+        <a:ea typeface=""/>
+        <a:cs typeface=""/>
+        <a:font script="Jpan" typeface="游ゴシック Light"/>
+        <a:font script="Hang" typeface="맑은 고딕"/>
+        <a:font script="Hans" typeface="等线 Light"/>
+        <a:font script="Hant" typeface="新細明體"/>
+        <a:font script="Arab" typeface="Times New Roman"/>
+        <a:font script="Hebr" typeface="Times New Roman"/>
+        <a:font script="Thai" typeface="Angsana New"/>
+        <a:font script="Ethi" typeface="Nyala"/>
+        <a:font script="Beng" typeface="Vrinda"/>
+        <a:font script="Gujr" typeface="Shruti"/>
+        <a:font script="Khmr" typeface="MoolBoran"/>
+        <a:font script="Knda" typeface="Tunga"/>
+        <a:font script="Guru" typeface="Raavi"/>
+        <a:font script="Cans" typeface="Euphemia"/>
+        <a:font script="Cher" typeface="Plantagenet Cherokee"/>
+        <a:font script="Yiii" typeface="Microsoft Yi Baiti"/>
+        <a:font script="Tibt" typeface="Microsoft Himalaya"/>
+        <a:font script="Thaa" typeface="MV Boli"/>
+        <a:font script="Deva" typeface="Mangal"/>
+        <a:font script="Telu" typeface="Gautami"/>
+        <a:font script="Taml" typeface="Latha"/>
+        <a:font script="Syrc" typeface="Estrangelo Edessa"/>
+        <a:font script="Orya" typeface="Kalinga"/>
+        <a:font script="Mlym" typeface="Kartika"/>
+        <a:font script="Laoo" typeface="DokChampa"/>
+        <a:font script="Sinh" typeface="Iskoola Pota"/>
+        <a:font script="Mong" typeface="Mongolian Baiti"/>
+        <a:font script="Viet" typeface="Times New Roman"/>
+        <a:font script="Uigh" typeface="Microsoft Uighur"/>
+        <a:font script="Geor" typeface="Sylfaen"/>
+        <a:font script="Armn" typeface="Arial"/>
+        <a:font script="Bugi" typeface="Leelawadee UI"/>
+        <a:font script="Bopo" typeface="Microsoft JhengHei"/>
+        <a:font script="Java" typeface="Javanese Text"/>
+        <a:font script="Lisu" typeface="Segoe UI"/>
+        <a:font script="Mymr" typeface="Myanmar Text"/>
+        <a:font script="Nkoo" typeface="Ebrima"/>
+        <a:font script="Olck" typeface="Nirmala UI"/>
+        <a:font script="Osma" typeface="Ebrima"/>
+        <a:font script="Phag" typeface="Phagspa"/>
+        <a:font script="Syrn" typeface="Estrangelo Edessa"/>
+        <a:font script="Syrj" typeface="Estrangelo Edessa"/>
+        <a:font script="Syre" typeface="Estrangelo Edessa"/>
+        <a:font script="Sora" typeface="Nirmala UI"/>
+        <a:font script="Tale" typeface="Microsoft Tai Le"/>
+        <a:font script="Talu" typeface="Microsoft New Tai Lue"/>
+        <a:font script="Tfng" typeface="Ebrima"/>
+      </a:majorFont>
+      <a:minorFont>
+        <a:latin typeface="Aptos" panose="02110004020202020204"/>
+        <a:ea typeface=""/>
+        <a:cs typeface=""/>
+        <a:font script="Jpan" typeface="游ゴシック"/>
+        <a:font script="Hang" typeface="맑은 고딕"/>
+        <a:font script="Hans" typeface="等线"/>
+        <a:font script="Hant" typeface="新細明體"/>
+        <a:font script="Arab" typeface="Arial"/>
+        <a:font script="Hebr" typeface="Arial"/>
+        <a:font script="Thai" typeface="Cordia New"/>
+        <a:font script="Ethi" typeface="Nyala"/>
+        <a:font script="Beng" typeface="Vrinda"/>
+        <a:font script="Gujr" typeface="Shruti"/>
+        <a:font script="Khmr" typeface="DaunPenh"/>
+        <a:font script="Knda" typeface="Tunga"/>
+        <a:font script="Guru" typeface="Raavi"/>
+        <a:font script="Cans" typeface="Euphemia"/>
+        <a:font script="Cher" typeface="Plantagenet Cherokee"/>
+        <a:font script="Yiii" typeface="Microsoft Yi Baiti"/>
+        <a:font script="Tibt" typeface="Microsoft Himalaya"/>
+        <a:font script="Thaa" typeface="MV Boli"/>
+        <a:font script="Deva" typeface="Mangal"/>
+        <a:font script="Telu" typeface="Gautami"/>
+        <a:font script="Taml" typeface="Latha"/>
+        <a:font script="Syrc" typeface="Estrangelo Edessa"/>
+        <a:font script="Orya" typeface="Kalinga"/>
+        <a:font script="Mlym" typeface="Kartika"/>
+        <a:font script="Laoo" typeface="DokChampa"/>
+        <a:font script="Sinh" typeface="Iskoola Pota"/>
+        <a:font script="Mong" typeface="Mongolian Baiti"/>
+        <a:font script="Viet" typeface="Arial"/>
+        <a:font script="Uigh" typeface="Microsoft Uighur"/>
+        <a:font script="Geor" typeface="Sylfaen"/>
+        <a:font script="Armn" typeface="Arial"/>
+        <a:font script="Bugi" typeface="Leelawadee UI"/>
+        <a:font script="Bopo" typeface="Microsoft JhengHei"/>
+        <a:font script="Java" typeface="Javanese Text"/>
+        <a:font script="Lisu" typeface="Segoe UI"/>
+        <a:font script="Mymr" typeface="Myanmar Text"/>
+        <a:font script="Nkoo" typeface="Ebrima"/>
+        <a:font script="Olck" typeface="Nirmala UI"/>
+        <a:font script="Osma" typeface="Ebrima"/>
+        <a:font script="Phag" typeface="Phagspa"/>
+        <a:font script="Syrn" typeface="Estrangelo Edessa"/>
+        <a:font script="Syrj" typeface="Estrangelo Edessa"/>
+        <a:font script="Syre" typeface="Estrangelo Edessa"/>
+        <a:font script="Sora" typeface="Nirmala UI"/>
+        <a:font script="Tale" typeface="Microsoft Tai Le"/>
+        <a:font script="Talu" typeface="Microsoft New Tai Lue"/>
+        <a:font script="Tfng" typeface="Ebrima"/>
+      </a:minorFont>
+    </a:fontScheme>
+    <a:fmtScheme name="Office">
+      <a:fillStyleLst>
+        <a:solidFill>
+          <a:schemeClr val="phClr"/>
+        </a:solidFill>
+        <a:gradFill rotWithShape="1">
+          <a:gsLst>
+            <a:gs pos="0">
+              <a:schemeClr val="phClr">
+                <a:lumMod val="110000"/>
+                <a:satMod val="105000"/>
+                <a:tint val="67000"/>
+              </a:schemeClr>
+            </a:gs>
+            <a:gs pos="50000">
+              <a:schemeClr val="phClr">
+                <a:lumMod val="105000"/>
+                <a:satMod val="103000"/>
+                <a:tint val="73000"/>
+              </a:schemeClr>
+            </a:gs>
+            <a:gs pos="100000">
+              <a:schemeClr val="phClr">
+                <a:lumMod val="105000"/>
+                <a:satMod val="109000"/>
+                <a:tint val="81000"/>
+              </a:schemeClr>
+            </a:gs>
+          </a:gsLst>
+          <a:lin ang="5400000" scaled="0"/>
+        </a:gradFill>
+        <a:gradFill rotWithShape="1">
+          <a:gsLst>
+            <a:gs pos="0">
+              <a:schemeClr val="phClr">
+                <a:satMod val="103000"/>
+                <a:lumMod val="102000"/>
+                <a:tint val="94000"/>
+              </a:schemeClr>
+            </a:gs>
+            <a:gs pos="50000">
+              <a:schemeClr val="phClr">
+                <a:satMod val="110000"/>
+                <a:lumMod val="100000"/>
+                <a:shade val="100000"/>
+              </a:schemeClr>
+            </a:gs>
+            <a:gs pos="100000">
+              <a:schemeClr val="phClr">
+                <a:lumMod val="99000"/>
+                <a:satMod val="120000"/>
+                <a:shade val="78000"/>
+              </a:schemeClr>
+            </a:gs>
+          </a:gsLst>
+          <a:lin ang="5400000" scaled="0"/>
+        </a:gradFill>
+      </a:fillStyleLst>
+      <a:lnStyleLst>
+        <a:ln w="12700" cap="flat" cmpd="sng" algn="ctr">
+          <a:solidFill>
+            <a:schemeClr val="phClr"/>
+          </a:solidFill>
+          <a:prstDash val="solid"/>
+          <a:miter lim="800000"/>
+        </a:ln>
+        <a:ln w="19050" cap="flat" cmpd="sng" algn="ctr">
+          <a:solidFill>
+            <a:schemeClr val="phClr"/>
+          </a:solidFill>
+          <a:prstDash val="solid"/>
+          <a:miter lim="800000"/>
+        </a:ln>
+        <a:ln w="25400" cap="flat" cmpd="sng" algn="ctr">
+          <a:solidFill>
+            <a:schemeClr val="phClr"/>
+          </a:solidFill>
+          <a:prstDash val="solid"/>
+          <a:miter lim="800000"/>
+        </a:ln>
+      </a:lnStyleLst>
+      <a:effectStyleLst>
+        <a:effectStyle>
+          <a:effectLst/>
+        </a:effectStyle>
+        <a:effectStyle>
+          <a:effectLst/>
+        </a:effectStyle>
+        <a:effectStyle>
+          <a:effectLst>
+            <a:outerShdw blurRad="57150" dist="19050" dir="5400000" algn="ctr" rotWithShape="0">
+              <a:srgbClr val="000000">
+                <a:alpha val="63000"/>
+              </a:srgbClr>
+            </a:outerShdw>
+          </a:effectLst>
+        </a:effectStyle>
+      </a:effectStyleLst>
+      <a:bgFillStyleLst>
+        <a:solidFill>
+          <a:schemeClr val="phClr"/>
+        </a:solidFill>
+        <a:solidFill>
+          <a:schemeClr val="phClr">
+            <a:tint val="95000"/>
+            <a:satMod val="170000"/>
+          </a:schemeClr>
+        </a:solidFill>
+        <a:gradFill rotWithShape="1">
+          <a:gsLst>
+            <a:gs pos="0">
+              <a:schemeClr val="phClr">
+                <a:tint val="93000"/>
+                <a:satMod val="150000"/>
+                <a:shade val="98000"/>
+                <a:lumMod val="102000"/>
+              </a:schemeClr>
+            </a:gs>
+            <a:gs pos="50000">
+              <a:schemeClr val="phClr">
+                <a:tint val="98000"/>
+                <a:satMod val="130000"/>
+                <a:shade val="90000"/>
+                <a:lumMod val="103000"/>
+              </a:schemeClr>
+            </a:gs>
+            <a:gs pos="100000">
+              <a:schemeClr val="phClr">
+                <a:shade val="63000"/>
+                <a:satMod val="120000"/>
+              </a:schemeClr>
+            </a:gs>
+          </a:gsLst>
+          <a:lin ang="5400000" scaled="0"/>
+        </a:gradFill>
+      </a:bgFillStyleLst>
+    </a:fmtScheme>
+  </a:themeElements>
+  <a:objectDefaults>
+    <a:lnDef>
+      <a:spPr/>
+      <a:bodyPr/>
+      <a:lstStyle/>
+      <a:style>
+        <a:lnRef idx="2">
+          <a:schemeClr val="accent1"/>
+        </a:lnRef>
+        <a:fillRef idx="0">
+          <a:schemeClr val="accent1"/>
+        </a:fillRef>
+        <a:effectRef idx="1">
+          <a:schemeClr val="accent1"/>
+        </a:effectRef>
+        <a:fontRef idx="minor">
+          <a:schemeClr val="tx1"/>
+        </a:fontRef>
+      </a:style>
+    </a:lnDef>
+  </a:objectDefaults>
+  <a:extraClrSchemeLst/>
+  <a:extLst>
+    <a:ext uri="{05A4C25C-085E-4340-85A3-A5531E510DB2}">
+      <thm15:themeFamily xmlns:thm15="http://schemas.microsoft.com/office/thememl/2012/main" name="Office Theme" id="{2E142A2C-CD16-42D6-873A-C26D2A0506FA}" vid="{1BDDFF52-6CD6-40A5-AB3C-68EB2F1E4D0A}"/>
+    </a:ext>
+  </a:extLst>
+</a:theme>
 </file>
</xml_diff>